<commit_message>
build(delivery): rebuild all S1 decks with auto-fit text (CL1+CL2+CL3)
Regenerate every topic deck so the bounded text auto-fit + vertical-centring
applies uniformly — light slides upsize to fill the page, dense stay at 18pt.
33 decks rebuilt; QA'd via review-slides (0 placeholders, 0 sparse slides, no
text overflow).

Co-Authored-By: Claude Opus 4.8 (1M context) <noreply@anthropic.com>
</commit_message>
<xml_diff>
--- a/S1-CL1-Cloud-Design-Build/delivery/topic_02/Topic_02_Slides.pptx
+++ b/S1-CL1-Cloud-Design-Build/delivery/topic_02/Topic_02_Slides.pptx
@@ -4355,8 +4355,8 @@
         </p:nvSpPr>
         <p:spPr>
           <a:xfrm>
-            <a:off x="640080" y="502920"/>
-            <a:ext cx="10881360" cy="1005840"/>
+            <a:off x="640080" y="457200"/>
+            <a:ext cx="10881360" cy="960120"/>
           </a:xfrm>
           <a:prstGeom prst="rect">
             <a:avLst/>
@@ -4370,7 +4370,7 @@
           <a:lstStyle/>
           <a:p>
             <a:r>
-              <a:rPr sz="3000" b="1" i="0">
+              <a:rPr sz="2800" b="1" i="0">
                 <a:solidFill>
                   <a:srgbClr val="2A2929"/>
                 </a:solidFill>
@@ -4389,7 +4389,7 @@
         </p:nvSpPr>
         <p:spPr>
           <a:xfrm>
-            <a:off x="658368" y="1481328"/>
+            <a:off x="658368" y="1371600"/>
             <a:ext cx="1463040" cy="50800"/>
           </a:xfrm>
           <a:prstGeom prst="rect">
@@ -4433,8 +4433,8 @@
         </p:nvSpPr>
         <p:spPr>
           <a:xfrm>
-            <a:off x="658368" y="1783080"/>
-            <a:ext cx="10881360" cy="4389120"/>
+            <a:off x="658368" y="1691640"/>
+            <a:ext cx="10881360" cy="4480560"/>
           </a:xfrm>
           <a:prstGeom prst="rect">
             <a:avLst/>
@@ -4442,7 +4442,7 @@
           <a:noFill/>
         </p:spPr>
         <p:txBody>
-          <a:bodyPr wrap="square" anchor="t" lIns="0" rIns="0" tIns="0" bIns="0">
+          <a:bodyPr wrap="square" anchor="ctr" lIns="0" rIns="0" tIns="0" bIns="0">
             <a:spAutoFit/>
           </a:bodyPr>
           <a:lstStyle/>
@@ -4459,7 +4459,7 @@
               </a:spcAft>
             </a:pPr>
             <a:r>
-              <a:rPr sz="1800" b="1" i="0">
+              <a:rPr sz="2400" b="1" i="0">
                 <a:solidFill>
                   <a:srgbClr val="EDAB0C"/>
                 </a:solidFill>
@@ -4468,7 +4468,7 @@
               <a:t>■  </a:t>
             </a:r>
             <a:r>
-              <a:rPr sz="1800" b="0" i="0">
+              <a:rPr sz="2400" b="0" i="0">
                 <a:solidFill>
                   <a:srgbClr val="2A2929"/>
                 </a:solidFill>
@@ -4490,7 +4490,7 @@
               </a:spcAft>
             </a:pPr>
             <a:r>
-              <a:rPr sz="1800" b="1" i="0">
+              <a:rPr sz="2400" b="1" i="0">
                 <a:solidFill>
                   <a:srgbClr val="EDAB0C"/>
                 </a:solidFill>
@@ -4499,7 +4499,7 @@
               <a:t>■  </a:t>
             </a:r>
             <a:r>
-              <a:rPr sz="1800" b="0" i="0">
+              <a:rPr sz="2400" b="0" i="0">
                 <a:solidFill>
                   <a:srgbClr val="2A2929"/>
                 </a:solidFill>
@@ -4521,7 +4521,7 @@
               </a:spcAft>
             </a:pPr>
             <a:r>
-              <a:rPr sz="1800" b="1" i="0">
+              <a:rPr sz="2400" b="1" i="0">
                 <a:solidFill>
                   <a:srgbClr val="EDAB0C"/>
                 </a:solidFill>
@@ -4530,7 +4530,7 @@
               <a:t>■  </a:t>
             </a:r>
             <a:r>
-              <a:rPr sz="1800" b="1" i="0">
+              <a:rPr sz="2400" b="1" i="0">
                 <a:solidFill>
                   <a:srgbClr val="D68E10"/>
                 </a:solidFill>
@@ -4697,8 +4697,8 @@
         </p:nvSpPr>
         <p:spPr>
           <a:xfrm>
-            <a:off x="640080" y="502920"/>
-            <a:ext cx="10881360" cy="1005840"/>
+            <a:off x="640080" y="457200"/>
+            <a:ext cx="10881360" cy="960120"/>
           </a:xfrm>
           <a:prstGeom prst="rect">
             <a:avLst/>
@@ -4712,7 +4712,7 @@
           <a:lstStyle/>
           <a:p>
             <a:r>
-              <a:rPr sz="3000" b="1" i="0">
+              <a:rPr sz="2800" b="1" i="0">
                 <a:solidFill>
                   <a:srgbClr val="2A2929"/>
                 </a:solidFill>
@@ -4747,7 +4747,7 @@
         </p:nvSpPr>
         <p:spPr>
           <a:xfrm>
-            <a:off x="658368" y="1481328"/>
+            <a:off x="658368" y="1371600"/>
             <a:ext cx="1463040" cy="50800"/>
           </a:xfrm>
           <a:prstGeom prst="rect">
@@ -4791,8 +4791,8 @@
         </p:nvSpPr>
         <p:spPr>
           <a:xfrm>
-            <a:off x="658368" y="1783080"/>
-            <a:ext cx="10881360" cy="4389120"/>
+            <a:off x="658368" y="1691640"/>
+            <a:ext cx="10881360" cy="4480560"/>
           </a:xfrm>
           <a:prstGeom prst="rect">
             <a:avLst/>
@@ -4800,7 +4800,7 @@
           <a:noFill/>
         </p:spPr>
         <p:txBody>
-          <a:bodyPr wrap="square" anchor="t" lIns="0" rIns="0" tIns="0" bIns="0">
+          <a:bodyPr wrap="square" anchor="ctr" lIns="0" rIns="0" tIns="0" bIns="0">
             <a:spAutoFit/>
           </a:bodyPr>
           <a:lstStyle/>
@@ -4817,7 +4817,7 @@
               </a:spcAft>
             </a:pPr>
             <a:r>
-              <a:rPr sz="1800" b="1" i="0">
+              <a:rPr sz="2400" b="1" i="0">
                 <a:solidFill>
                   <a:srgbClr val="EDAB0C"/>
                 </a:solidFill>
@@ -4826,7 +4826,7 @@
               <a:t>■  </a:t>
             </a:r>
             <a:r>
-              <a:rPr sz="1800" b="1" i="0">
+              <a:rPr sz="2400" b="1" i="0">
                 <a:solidFill>
                   <a:srgbClr val="2A2929"/>
                 </a:solidFill>
@@ -4848,7 +4848,7 @@
               </a:spcAft>
             </a:pPr>
             <a:r>
-              <a:rPr sz="1500" b="0" i="0">
+              <a:rPr sz="2100" b="0" i="0">
                 <a:solidFill>
                   <a:srgbClr val="7A7A7A"/>
                 </a:solidFill>
@@ -4857,7 +4857,7 @@
               <a:t>–  </a:t>
             </a:r>
             <a:r>
-              <a:rPr sz="1500" b="0" i="0">
+              <a:rPr sz="2100" b="0" i="0">
                 <a:solidFill>
                   <a:srgbClr val="2A2929"/>
                 </a:solidFill>
@@ -4879,7 +4879,7 @@
               </a:spcAft>
             </a:pPr>
             <a:r>
-              <a:rPr sz="1800" b="1" i="0">
+              <a:rPr sz="2400" b="1" i="0">
                 <a:solidFill>
                   <a:srgbClr val="EDAB0C"/>
                 </a:solidFill>
@@ -4888,7 +4888,7 @@
               <a:t>■  </a:t>
             </a:r>
             <a:r>
-              <a:rPr sz="1800" b="1" i="0">
+              <a:rPr sz="2400" b="1" i="0">
                 <a:solidFill>
                   <a:srgbClr val="2A2929"/>
                 </a:solidFill>
@@ -4910,7 +4910,7 @@
               </a:spcAft>
             </a:pPr>
             <a:r>
-              <a:rPr sz="1500" b="0" i="0">
+              <a:rPr sz="2100" b="0" i="0">
                 <a:solidFill>
                   <a:srgbClr val="7A7A7A"/>
                 </a:solidFill>
@@ -4919,7 +4919,7 @@
               <a:t>–  </a:t>
             </a:r>
             <a:r>
-              <a:rPr sz="1500" b="0" i="0">
+              <a:rPr sz="2100" b="0" i="0">
                 <a:solidFill>
                   <a:srgbClr val="2A2929"/>
                 </a:solidFill>
@@ -4941,7 +4941,7 @@
               </a:spcAft>
             </a:pPr>
             <a:r>
-              <a:rPr sz="1800" b="1" i="0">
+              <a:rPr sz="2400" b="1" i="0">
                 <a:solidFill>
                   <a:srgbClr val="27B5CE"/>
                 </a:solidFill>
@@ -4950,7 +4950,7 @@
               <a:t>■  </a:t>
             </a:r>
             <a:r>
-              <a:rPr sz="1800" b="1" i="0">
+              <a:rPr sz="2400" b="1" i="0">
                 <a:solidFill>
                   <a:srgbClr val="27B5CE"/>
                 </a:solidFill>
@@ -5117,8 +5117,8 @@
         </p:nvSpPr>
         <p:spPr>
           <a:xfrm>
-            <a:off x="640080" y="502920"/>
-            <a:ext cx="10881360" cy="1005840"/>
+            <a:off x="640080" y="457200"/>
+            <a:ext cx="10881360" cy="960120"/>
           </a:xfrm>
           <a:prstGeom prst="rect">
             <a:avLst/>
@@ -5132,7 +5132,7 @@
           <a:lstStyle/>
           <a:p>
             <a:r>
-              <a:rPr sz="3000" b="1" i="0">
+              <a:rPr sz="2800" b="1" i="0">
                 <a:solidFill>
                   <a:srgbClr val="2A2929"/>
                 </a:solidFill>
@@ -5151,7 +5151,7 @@
         </p:nvSpPr>
         <p:spPr>
           <a:xfrm>
-            <a:off x="658368" y="1481328"/>
+            <a:off x="658368" y="1371600"/>
             <a:ext cx="1463040" cy="50800"/>
           </a:xfrm>
           <a:prstGeom prst="rect">
@@ -5195,8 +5195,8 @@
         </p:nvSpPr>
         <p:spPr>
           <a:xfrm>
-            <a:off x="658368" y="1783080"/>
-            <a:ext cx="10881360" cy="4389120"/>
+            <a:off x="658368" y="1691640"/>
+            <a:ext cx="10881360" cy="4480560"/>
           </a:xfrm>
           <a:prstGeom prst="rect">
             <a:avLst/>
@@ -5204,7 +5204,7 @@
           <a:noFill/>
         </p:spPr>
         <p:txBody>
-          <a:bodyPr wrap="square" anchor="t" lIns="0" rIns="0" tIns="0" bIns="0">
+          <a:bodyPr wrap="square" anchor="ctr" lIns="0" rIns="0" tIns="0" bIns="0">
             <a:spAutoFit/>
           </a:bodyPr>
           <a:lstStyle/>
@@ -5221,7 +5221,7 @@
               </a:spcAft>
             </a:pPr>
             <a:r>
-              <a:rPr sz="1800" b="1" i="0">
+              <a:rPr sz="2400" b="1" i="0">
                 <a:solidFill>
                   <a:srgbClr val="EDAB0C"/>
                 </a:solidFill>
@@ -5230,7 +5230,7 @@
               <a:t>■  </a:t>
             </a:r>
             <a:r>
-              <a:rPr sz="1800" b="0" i="0">
+              <a:rPr sz="2400" b="0" i="0">
                 <a:solidFill>
                   <a:srgbClr val="2A2929"/>
                 </a:solidFill>
@@ -5252,7 +5252,7 @@
               </a:spcAft>
             </a:pPr>
             <a:r>
-              <a:rPr sz="1800" b="1" i="0">
+              <a:rPr sz="2400" b="1" i="0">
                 <a:solidFill>
                   <a:srgbClr val="EDAB0C"/>
                 </a:solidFill>
@@ -5261,7 +5261,7 @@
               <a:t>■  </a:t>
             </a:r>
             <a:r>
-              <a:rPr sz="1800" b="0" i="0">
+              <a:rPr sz="2400" b="0" i="0">
                 <a:solidFill>
                   <a:srgbClr val="2A2929"/>
                 </a:solidFill>
@@ -5283,7 +5283,7 @@
               </a:spcAft>
             </a:pPr>
             <a:r>
-              <a:rPr sz="1800" b="1" i="0">
+              <a:rPr sz="2400" b="1" i="0">
                 <a:solidFill>
                   <a:srgbClr val="EDAB0C"/>
                 </a:solidFill>
@@ -5292,7 +5292,7 @@
               <a:t>■  </a:t>
             </a:r>
             <a:r>
-              <a:rPr sz="1800" b="0" i="0">
+              <a:rPr sz="2400" b="0" i="0">
                 <a:solidFill>
                   <a:srgbClr val="2A2929"/>
                 </a:solidFill>
@@ -5314,7 +5314,7 @@
               </a:spcAft>
             </a:pPr>
             <a:r>
-              <a:rPr sz="1800" b="1" i="0">
+              <a:rPr sz="2400" b="1" i="0">
                 <a:solidFill>
                   <a:srgbClr val="EDAB0C"/>
                 </a:solidFill>
@@ -5323,7 +5323,7 @@
               <a:t>■  </a:t>
             </a:r>
             <a:r>
-              <a:rPr sz="1800" b="1" i="0">
+              <a:rPr sz="2400" b="1" i="0">
                 <a:solidFill>
                   <a:srgbClr val="D68E10"/>
                 </a:solidFill>
@@ -5563,7 +5563,7 @@
           </a:fontRef>
         </p:style>
         <p:txBody>
-          <a:bodyPr rtlCol="0" anchor="ctr" wrap="none"/>
+          <a:bodyPr rtlCol="0" anchor="ctr"/>
           <a:lstStyle/>
           <a:p>
             <a:pPr algn="ctr"/>
@@ -6979,8 +6979,8 @@
         </p:nvSpPr>
         <p:spPr>
           <a:xfrm>
-            <a:off x="640080" y="502920"/>
-            <a:ext cx="10881360" cy="1005840"/>
+            <a:off x="640080" y="457200"/>
+            <a:ext cx="10881360" cy="960120"/>
           </a:xfrm>
           <a:prstGeom prst="rect">
             <a:avLst/>
@@ -6994,7 +6994,7 @@
           <a:lstStyle/>
           <a:p>
             <a:r>
-              <a:rPr sz="3000" b="1" i="0">
+              <a:rPr sz="2800" b="1" i="0">
                 <a:solidFill>
                   <a:srgbClr val="2A2929"/>
                 </a:solidFill>
@@ -7013,7 +7013,7 @@
         </p:nvSpPr>
         <p:spPr>
           <a:xfrm>
-            <a:off x="658368" y="1481328"/>
+            <a:off x="658368" y="1371600"/>
             <a:ext cx="1463040" cy="50800"/>
           </a:xfrm>
           <a:prstGeom prst="rect">
@@ -7057,8 +7057,8 @@
         </p:nvSpPr>
         <p:spPr>
           <a:xfrm>
-            <a:off x="658368" y="1783080"/>
-            <a:ext cx="10881360" cy="4389120"/>
+            <a:off x="658368" y="1691640"/>
+            <a:ext cx="10881360" cy="4480560"/>
           </a:xfrm>
           <a:prstGeom prst="rect">
             <a:avLst/>
@@ -7066,7 +7066,7 @@
           <a:noFill/>
         </p:spPr>
         <p:txBody>
-          <a:bodyPr wrap="square" anchor="t" lIns="0" rIns="0" tIns="0" bIns="0">
+          <a:bodyPr wrap="square" anchor="ctr" lIns="0" rIns="0" tIns="0" bIns="0">
             <a:spAutoFit/>
           </a:bodyPr>
           <a:lstStyle/>
@@ -7083,7 +7083,7 @@
               </a:spcAft>
             </a:pPr>
             <a:r>
-              <a:rPr sz="1800" b="1" i="0">
+              <a:rPr sz="2400" b="1" i="0">
                 <a:solidFill>
                   <a:srgbClr val="EDAB0C"/>
                 </a:solidFill>
@@ -7092,7 +7092,7 @@
               <a:t>■  </a:t>
             </a:r>
             <a:r>
-              <a:rPr sz="1800" b="0" i="0">
+              <a:rPr sz="2400" b="0" i="0">
                 <a:solidFill>
                   <a:srgbClr val="2A2929"/>
                 </a:solidFill>
@@ -7114,7 +7114,7 @@
               </a:spcAft>
             </a:pPr>
             <a:r>
-              <a:rPr sz="1800" b="1" i="0">
+              <a:rPr sz="2400" b="1" i="0">
                 <a:solidFill>
                   <a:srgbClr val="EDAB0C"/>
                 </a:solidFill>
@@ -7123,7 +7123,7 @@
               <a:t>■  </a:t>
             </a:r>
             <a:r>
-              <a:rPr sz="1800" b="0" i="0">
+              <a:rPr sz="2400" b="0" i="0">
                 <a:solidFill>
                   <a:srgbClr val="2A2929"/>
                 </a:solidFill>
@@ -7145,7 +7145,7 @@
               </a:spcAft>
             </a:pPr>
             <a:r>
-              <a:rPr sz="1800" b="1" i="0">
+              <a:rPr sz="2400" b="1" i="0">
                 <a:solidFill>
                   <a:srgbClr val="EDAB0C"/>
                 </a:solidFill>
@@ -7154,7 +7154,7 @@
               <a:t>■  </a:t>
             </a:r>
             <a:r>
-              <a:rPr sz="1800" b="0" i="0">
+              <a:rPr sz="2400" b="0" i="0">
                 <a:solidFill>
                   <a:srgbClr val="2A2929"/>
                 </a:solidFill>
@@ -7176,7 +7176,7 @@
               </a:spcAft>
             </a:pPr>
             <a:r>
-              <a:rPr sz="1800" b="1" i="0">
+              <a:rPr sz="2400" b="1" i="0">
                 <a:solidFill>
                   <a:srgbClr val="205F61"/>
                 </a:solidFill>
@@ -7185,7 +7185,7 @@
               <a:t>■  </a:t>
             </a:r>
             <a:r>
-              <a:rPr sz="1800" b="1" i="0">
+              <a:rPr sz="2400" b="1" i="0">
                 <a:solidFill>
                   <a:srgbClr val="205F61"/>
                 </a:solidFill>
@@ -7352,8 +7352,8 @@
         </p:nvSpPr>
         <p:spPr>
           <a:xfrm>
-            <a:off x="640080" y="502920"/>
-            <a:ext cx="10881360" cy="1005840"/>
+            <a:off x="640080" y="457200"/>
+            <a:ext cx="10881360" cy="960120"/>
           </a:xfrm>
           <a:prstGeom prst="rect">
             <a:avLst/>
@@ -7367,7 +7367,7 @@
           <a:lstStyle/>
           <a:p>
             <a:r>
-              <a:rPr sz="3000" b="1" i="0">
+              <a:rPr sz="2800" b="1" i="0">
                 <a:solidFill>
                   <a:srgbClr val="2A2929"/>
                 </a:solidFill>
@@ -7402,7 +7402,7 @@
         </p:nvSpPr>
         <p:spPr>
           <a:xfrm>
-            <a:off x="658368" y="1481328"/>
+            <a:off x="658368" y="1371600"/>
             <a:ext cx="1463040" cy="50800"/>
           </a:xfrm>
           <a:prstGeom prst="rect">
@@ -7926,8 +7926,8 @@
         </p:nvSpPr>
         <p:spPr>
           <a:xfrm>
-            <a:off x="640080" y="502920"/>
-            <a:ext cx="10881360" cy="1005840"/>
+            <a:off x="640080" y="457200"/>
+            <a:ext cx="10881360" cy="960120"/>
           </a:xfrm>
           <a:prstGeom prst="rect">
             <a:avLst/>
@@ -7941,7 +7941,7 @@
           <a:lstStyle/>
           <a:p>
             <a:r>
-              <a:rPr sz="3000" b="1" i="0">
+              <a:rPr sz="2800" b="1" i="0">
                 <a:solidFill>
                   <a:srgbClr val="2A2929"/>
                 </a:solidFill>
@@ -7976,7 +7976,7 @@
         </p:nvSpPr>
         <p:spPr>
           <a:xfrm>
-            <a:off x="658368" y="1481328"/>
+            <a:off x="658368" y="1371600"/>
             <a:ext cx="1463040" cy="50800"/>
           </a:xfrm>
           <a:prstGeom prst="rect">
@@ -8020,8 +8020,8 @@
         </p:nvSpPr>
         <p:spPr>
           <a:xfrm>
-            <a:off x="658368" y="1783080"/>
-            <a:ext cx="10881360" cy="4389120"/>
+            <a:off x="658368" y="1691640"/>
+            <a:ext cx="10881360" cy="4480560"/>
           </a:xfrm>
           <a:prstGeom prst="rect">
             <a:avLst/>
@@ -8029,7 +8029,7 @@
           <a:noFill/>
         </p:spPr>
         <p:txBody>
-          <a:bodyPr wrap="square" anchor="t" lIns="0" rIns="0" tIns="0" bIns="0">
+          <a:bodyPr wrap="square" anchor="ctr" lIns="0" rIns="0" tIns="0" bIns="0">
             <a:spAutoFit/>
           </a:bodyPr>
           <a:lstStyle/>
@@ -8046,7 +8046,7 @@
               </a:spcAft>
             </a:pPr>
             <a:r>
-              <a:rPr sz="1800" b="1" i="0">
+              <a:rPr sz="2400" b="1" i="0">
                 <a:solidFill>
                   <a:srgbClr val="EDAB0C"/>
                 </a:solidFill>
@@ -8055,7 +8055,7 @@
               <a:t>■  </a:t>
             </a:r>
             <a:r>
-              <a:rPr sz="1800" b="0" i="0">
+              <a:rPr sz="2400" b="0" i="0">
                 <a:solidFill>
                   <a:srgbClr val="2A2929"/>
                 </a:solidFill>
@@ -8077,7 +8077,7 @@
               </a:spcAft>
             </a:pPr>
             <a:r>
-              <a:rPr sz="1800" b="1" i="0">
+              <a:rPr sz="2400" b="1" i="0">
                 <a:solidFill>
                   <a:srgbClr val="EDAB0C"/>
                 </a:solidFill>
@@ -8086,7 +8086,7 @@
               <a:t>■  </a:t>
             </a:r>
             <a:r>
-              <a:rPr sz="1800" b="0" i="0">
+              <a:rPr sz="2400" b="0" i="0">
                 <a:solidFill>
                   <a:srgbClr val="2A2929"/>
                 </a:solidFill>
@@ -8108,7 +8108,7 @@
               </a:spcAft>
             </a:pPr>
             <a:r>
-              <a:rPr sz="1800" b="1" i="0">
+              <a:rPr sz="2400" b="1" i="0">
                 <a:solidFill>
                   <a:srgbClr val="EDAB0C"/>
                 </a:solidFill>
@@ -8117,7 +8117,7 @@
               <a:t>■  </a:t>
             </a:r>
             <a:r>
-              <a:rPr sz="1800" b="1" i="0">
+              <a:rPr sz="2400" b="1" i="0">
                 <a:solidFill>
                   <a:srgbClr val="D68E10"/>
                 </a:solidFill>
@@ -8139,7 +8139,7 @@
               </a:spcAft>
             </a:pPr>
             <a:r>
-              <a:rPr sz="1800" b="1" i="0">
+              <a:rPr sz="2400" b="1" i="0">
                 <a:solidFill>
                   <a:srgbClr val="EDAB0C"/>
                 </a:solidFill>
@@ -8148,7 +8148,7 @@
               <a:t>■  </a:t>
             </a:r>
             <a:r>
-              <a:rPr sz="1800" b="0" i="0">
+              <a:rPr sz="2400" b="0" i="0">
                 <a:solidFill>
                   <a:srgbClr val="2A2929"/>
                 </a:solidFill>
@@ -8315,8 +8315,8 @@
         </p:nvSpPr>
         <p:spPr>
           <a:xfrm>
-            <a:off x="640080" y="502920"/>
-            <a:ext cx="10881360" cy="1005840"/>
+            <a:off x="640080" y="457200"/>
+            <a:ext cx="10881360" cy="960120"/>
           </a:xfrm>
           <a:prstGeom prst="rect">
             <a:avLst/>
@@ -8330,7 +8330,7 @@
           <a:lstStyle/>
           <a:p>
             <a:r>
-              <a:rPr sz="3000" b="1" i="0">
+              <a:rPr sz="2800" b="1" i="0">
                 <a:solidFill>
                   <a:srgbClr val="2A2929"/>
                 </a:solidFill>
@@ -8365,7 +8365,7 @@
         </p:nvSpPr>
         <p:spPr>
           <a:xfrm>
-            <a:off x="658368" y="1481328"/>
+            <a:off x="658368" y="1371600"/>
             <a:ext cx="1463040" cy="50800"/>
           </a:xfrm>
           <a:prstGeom prst="rect">
@@ -9012,7 +9012,7 @@
           </a:fontRef>
         </p:style>
         <p:txBody>
-          <a:bodyPr rtlCol="0" anchor="ctr" wrap="none"/>
+          <a:bodyPr rtlCol="0" anchor="ctr"/>
           <a:lstStyle/>
           <a:p>
             <a:pPr algn="ctr"/>
@@ -10242,8 +10242,8 @@
         </p:nvSpPr>
         <p:spPr>
           <a:xfrm>
-            <a:off x="914400" y="1371600"/>
-            <a:ext cx="10515600" cy="4114800"/>
+            <a:off x="914400" y="1463040"/>
+            <a:ext cx="10515600" cy="4023360"/>
           </a:xfrm>
           <a:prstGeom prst="rect">
             <a:avLst/>
@@ -10397,8 +10397,8 @@
         </p:nvSpPr>
         <p:spPr>
           <a:xfrm>
-            <a:off x="640080" y="502920"/>
-            <a:ext cx="10881360" cy="1005840"/>
+            <a:off x="640080" y="457200"/>
+            <a:ext cx="10881360" cy="960120"/>
           </a:xfrm>
           <a:prstGeom prst="rect">
             <a:avLst/>
@@ -10412,7 +10412,7 @@
           <a:lstStyle/>
           <a:p>
             <a:r>
-              <a:rPr sz="3000" b="1" i="0">
+              <a:rPr sz="2800" b="1" i="0">
                 <a:solidFill>
                   <a:srgbClr val="2A2929"/>
                 </a:solidFill>
@@ -10431,7 +10431,7 @@
         </p:nvSpPr>
         <p:spPr>
           <a:xfrm>
-            <a:off x="658368" y="1481328"/>
+            <a:off x="658368" y="1371600"/>
             <a:ext cx="1463040" cy="50800"/>
           </a:xfrm>
           <a:prstGeom prst="rect">
@@ -10475,8 +10475,8 @@
         </p:nvSpPr>
         <p:spPr>
           <a:xfrm>
-            <a:off x="658368" y="1783080"/>
-            <a:ext cx="10881360" cy="4389120"/>
+            <a:off x="658368" y="1691640"/>
+            <a:ext cx="10881360" cy="4480560"/>
           </a:xfrm>
           <a:prstGeom prst="rect">
             <a:avLst/>
@@ -10484,7 +10484,7 @@
           <a:noFill/>
         </p:spPr>
         <p:txBody>
-          <a:bodyPr wrap="square" anchor="t" lIns="0" rIns="0" tIns="0" bIns="0">
+          <a:bodyPr wrap="square" anchor="ctr" lIns="0" rIns="0" tIns="0" bIns="0">
             <a:spAutoFit/>
           </a:bodyPr>
           <a:lstStyle/>
@@ -10501,7 +10501,7 @@
               </a:spcAft>
             </a:pPr>
             <a:r>
-              <a:rPr sz="1800" b="1" i="0">
+              <a:rPr sz="2400" b="1" i="0">
                 <a:solidFill>
                   <a:srgbClr val="EDAB0C"/>
                 </a:solidFill>
@@ -10510,7 +10510,7 @@
               <a:t>■  </a:t>
             </a:r>
             <a:r>
-              <a:rPr sz="1800" b="0" i="0">
+              <a:rPr sz="2400" b="0" i="0">
                 <a:solidFill>
                   <a:srgbClr val="2A2929"/>
                 </a:solidFill>
@@ -10532,7 +10532,7 @@
               </a:spcAft>
             </a:pPr>
             <a:r>
-              <a:rPr sz="1500" b="0" i="0">
+              <a:rPr sz="2100" b="0" i="0">
                 <a:solidFill>
                   <a:srgbClr val="7A7A7A"/>
                 </a:solidFill>
@@ -10541,7 +10541,7 @@
               <a:t>–  </a:t>
             </a:r>
             <a:r>
-              <a:rPr sz="1500" b="0" i="0">
+              <a:rPr sz="2100" b="0" i="0">
                 <a:solidFill>
                   <a:srgbClr val="2A2929"/>
                 </a:solidFill>
@@ -10563,7 +10563,7 @@
               </a:spcAft>
             </a:pPr>
             <a:r>
-              <a:rPr sz="1500" b="0" i="0">
+              <a:rPr sz="2100" b="0" i="0">
                 <a:solidFill>
                   <a:srgbClr val="7A7A7A"/>
                 </a:solidFill>
@@ -10572,7 +10572,7 @@
               <a:t>–  </a:t>
             </a:r>
             <a:r>
-              <a:rPr sz="1500" b="0" i="0">
+              <a:rPr sz="2100" b="0" i="0">
                 <a:solidFill>
                   <a:srgbClr val="2A2929"/>
                 </a:solidFill>
@@ -10594,7 +10594,7 @@
               </a:spcAft>
             </a:pPr>
             <a:r>
-              <a:rPr sz="1500" b="0" i="0">
+              <a:rPr sz="2100" b="0" i="0">
                 <a:solidFill>
                   <a:srgbClr val="7A7A7A"/>
                 </a:solidFill>
@@ -10603,7 +10603,7 @@
               <a:t>–  </a:t>
             </a:r>
             <a:r>
-              <a:rPr sz="1500" b="0" i="0">
+              <a:rPr sz="2100" b="0" i="0">
                 <a:solidFill>
                   <a:srgbClr val="2A2929"/>
                 </a:solidFill>
@@ -10625,7 +10625,7 @@
               </a:spcAft>
             </a:pPr>
             <a:r>
-              <a:rPr sz="1800" b="1" i="0">
+              <a:rPr sz="2400" b="1" i="0">
                 <a:solidFill>
                   <a:srgbClr val="EDAB0C"/>
                 </a:solidFill>
@@ -10634,7 +10634,7 @@
               <a:t>■  </a:t>
             </a:r>
             <a:r>
-              <a:rPr sz="1800" b="0" i="0">
+              <a:rPr sz="2400" b="0" i="0">
                 <a:solidFill>
                   <a:srgbClr val="2A2929"/>
                 </a:solidFill>
@@ -10656,7 +10656,7 @@
               </a:spcAft>
             </a:pPr>
             <a:r>
-              <a:rPr sz="1800" b="1" i="0">
+              <a:rPr sz="2400" b="1" i="0">
                 <a:solidFill>
                   <a:srgbClr val="92268F"/>
                 </a:solidFill>
@@ -10665,7 +10665,7 @@
               <a:t>■  </a:t>
             </a:r>
             <a:r>
-              <a:rPr sz="1800" b="1" i="0">
+              <a:rPr sz="2400" b="1" i="0">
                 <a:solidFill>
                   <a:srgbClr val="92268F"/>
                 </a:solidFill>
@@ -11124,8 +11124,8 @@
         </p:nvSpPr>
         <p:spPr>
           <a:xfrm>
-            <a:off x="640080" y="502920"/>
-            <a:ext cx="10881360" cy="1005840"/>
+            <a:off x="640080" y="457200"/>
+            <a:ext cx="10881360" cy="960120"/>
           </a:xfrm>
           <a:prstGeom prst="rect">
             <a:avLst/>
@@ -11139,7 +11139,7 @@
           <a:lstStyle/>
           <a:p>
             <a:r>
-              <a:rPr sz="3000" b="1" i="0">
+              <a:rPr sz="2800" b="1" i="0">
                 <a:solidFill>
                   <a:srgbClr val="2A2929"/>
                 </a:solidFill>
@@ -11174,7 +11174,7 @@
         </p:nvSpPr>
         <p:spPr>
           <a:xfrm>
-            <a:off x="658368" y="1481328"/>
+            <a:off x="658368" y="1371600"/>
             <a:ext cx="1463040" cy="50800"/>
           </a:xfrm>
           <a:prstGeom prst="rect">
@@ -11218,8 +11218,8 @@
         </p:nvSpPr>
         <p:spPr>
           <a:xfrm>
-            <a:off x="658368" y="1783080"/>
-            <a:ext cx="10881360" cy="4389120"/>
+            <a:off x="658368" y="1691640"/>
+            <a:ext cx="10881360" cy="4480560"/>
           </a:xfrm>
           <a:prstGeom prst="rect">
             <a:avLst/>
@@ -11227,7 +11227,7 @@
           <a:noFill/>
         </p:spPr>
         <p:txBody>
-          <a:bodyPr wrap="square" anchor="t" lIns="0" rIns="0" tIns="0" bIns="0">
+          <a:bodyPr wrap="square" anchor="ctr" lIns="0" rIns="0" tIns="0" bIns="0">
             <a:spAutoFit/>
           </a:bodyPr>
           <a:lstStyle/>
@@ -11244,7 +11244,7 @@
               </a:spcAft>
             </a:pPr>
             <a:r>
-              <a:rPr sz="1800" b="1" i="0">
+              <a:rPr sz="2400" b="1" i="0">
                 <a:solidFill>
                   <a:srgbClr val="EDAB0C"/>
                 </a:solidFill>
@@ -11253,7 +11253,7 @@
               <a:t>■  </a:t>
             </a:r>
             <a:r>
-              <a:rPr sz="1800" b="0" i="0">
+              <a:rPr sz="2400" b="0" i="0">
                 <a:solidFill>
                   <a:srgbClr val="2A2929"/>
                 </a:solidFill>
@@ -11275,7 +11275,7 @@
               </a:spcAft>
             </a:pPr>
             <a:r>
-              <a:rPr sz="1800" b="1" i="0">
+              <a:rPr sz="2400" b="1" i="0">
                 <a:solidFill>
                   <a:srgbClr val="EDAB0C"/>
                 </a:solidFill>
@@ -11284,7 +11284,7 @@
               <a:t>■  </a:t>
             </a:r>
             <a:r>
-              <a:rPr sz="1800" b="0" i="0">
+              <a:rPr sz="2400" b="0" i="0">
                 <a:solidFill>
                   <a:srgbClr val="2A2929"/>
                 </a:solidFill>
@@ -11306,7 +11306,7 @@
               </a:spcAft>
             </a:pPr>
             <a:r>
-              <a:rPr sz="1800" b="1" i="0">
+              <a:rPr sz="2400" b="1" i="0">
                 <a:solidFill>
                   <a:srgbClr val="EDAB0C"/>
                 </a:solidFill>
@@ -11315,7 +11315,7 @@
               <a:t>■  </a:t>
             </a:r>
             <a:r>
-              <a:rPr sz="1800" b="0" i="0">
+              <a:rPr sz="2400" b="0" i="0">
                 <a:solidFill>
                   <a:srgbClr val="2A2929"/>
                 </a:solidFill>
@@ -11337,7 +11337,7 @@
               </a:spcAft>
             </a:pPr>
             <a:r>
-              <a:rPr sz="1800" b="1" i="0">
+              <a:rPr sz="2400" b="1" i="0">
                 <a:solidFill>
                   <a:srgbClr val="EDAB0C"/>
                 </a:solidFill>
@@ -11346,7 +11346,7 @@
               <a:t>■  </a:t>
             </a:r>
             <a:r>
-              <a:rPr sz="1800" b="1" i="0">
+              <a:rPr sz="2400" b="1" i="0">
                 <a:solidFill>
                   <a:srgbClr val="D68E10"/>
                 </a:solidFill>
@@ -11513,8 +11513,8 @@
         </p:nvSpPr>
         <p:spPr>
           <a:xfrm>
-            <a:off x="640080" y="502920"/>
-            <a:ext cx="10881360" cy="1005840"/>
+            <a:off x="640080" y="457200"/>
+            <a:ext cx="10881360" cy="960120"/>
           </a:xfrm>
           <a:prstGeom prst="rect">
             <a:avLst/>
@@ -11528,7 +11528,7 @@
           <a:lstStyle/>
           <a:p>
             <a:r>
-              <a:rPr sz="3000" b="1" i="0">
+              <a:rPr sz="2800" b="1" i="0">
                 <a:solidFill>
                   <a:srgbClr val="2A2929"/>
                 </a:solidFill>
@@ -11547,7 +11547,7 @@
         </p:nvSpPr>
         <p:spPr>
           <a:xfrm>
-            <a:off x="658368" y="1481328"/>
+            <a:off x="658368" y="1371600"/>
             <a:ext cx="1463040" cy="50800"/>
           </a:xfrm>
           <a:prstGeom prst="rect">
@@ -11591,8 +11591,8 @@
         </p:nvSpPr>
         <p:spPr>
           <a:xfrm>
-            <a:off x="658368" y="1783080"/>
-            <a:ext cx="10881360" cy="4389120"/>
+            <a:off x="658368" y="1691640"/>
+            <a:ext cx="10881360" cy="4480560"/>
           </a:xfrm>
           <a:prstGeom prst="rect">
             <a:avLst/>
@@ -11600,7 +11600,7 @@
           <a:noFill/>
         </p:spPr>
         <p:txBody>
-          <a:bodyPr wrap="square" anchor="t" lIns="0" rIns="0" tIns="0" bIns="0">
+          <a:bodyPr wrap="square" anchor="ctr" lIns="0" rIns="0" tIns="0" bIns="0">
             <a:spAutoFit/>
           </a:bodyPr>
           <a:lstStyle/>
@@ -11617,7 +11617,7 @@
               </a:spcAft>
             </a:pPr>
             <a:r>
-              <a:rPr sz="1800" b="1" i="0">
+              <a:rPr sz="2400" b="1" i="0">
                 <a:solidFill>
                   <a:srgbClr val="EDAB0C"/>
                 </a:solidFill>
@@ -11626,7 +11626,7 @@
               <a:t>■  </a:t>
             </a:r>
             <a:r>
-              <a:rPr sz="1800" b="1" i="0">
+              <a:rPr sz="2400" b="1" i="0">
                 <a:solidFill>
                   <a:srgbClr val="2A2929"/>
                 </a:solidFill>
@@ -11648,7 +11648,7 @@
               </a:spcAft>
             </a:pPr>
             <a:r>
-              <a:rPr sz="1500" b="0" i="0">
+              <a:rPr sz="2100" b="0" i="0">
                 <a:solidFill>
                   <a:srgbClr val="7A7A7A"/>
                 </a:solidFill>
@@ -11657,7 +11657,7 @@
               <a:t>–  </a:t>
             </a:r>
             <a:r>
-              <a:rPr sz="1500" b="0" i="0">
+              <a:rPr sz="2100" b="0" i="0">
                 <a:solidFill>
                   <a:srgbClr val="2A2929"/>
                 </a:solidFill>
@@ -11679,7 +11679,7 @@
               </a:spcAft>
             </a:pPr>
             <a:r>
-              <a:rPr sz="1800" b="1" i="0">
+              <a:rPr sz="2400" b="1" i="0">
                 <a:solidFill>
                   <a:srgbClr val="EDAB0C"/>
                 </a:solidFill>
@@ -11688,7 +11688,7 @@
               <a:t>■  </a:t>
             </a:r>
             <a:r>
-              <a:rPr sz="1800" b="1" i="0">
+              <a:rPr sz="2400" b="1" i="0">
                 <a:solidFill>
                   <a:srgbClr val="2A2929"/>
                 </a:solidFill>
@@ -11710,7 +11710,7 @@
               </a:spcAft>
             </a:pPr>
             <a:r>
-              <a:rPr sz="1500" b="0" i="0">
+              <a:rPr sz="2100" b="0" i="0">
                 <a:solidFill>
                   <a:srgbClr val="7A7A7A"/>
                 </a:solidFill>
@@ -11719,7 +11719,7 @@
               <a:t>–  </a:t>
             </a:r>
             <a:r>
-              <a:rPr sz="1500" b="0" i="0">
+              <a:rPr sz="2100" b="0" i="0">
                 <a:solidFill>
                   <a:srgbClr val="2A2929"/>
                 </a:solidFill>
@@ -11741,7 +11741,7 @@
               </a:spcAft>
             </a:pPr>
             <a:r>
-              <a:rPr sz="1800" b="1" i="0">
+              <a:rPr sz="2400" b="1" i="0">
                 <a:solidFill>
                   <a:srgbClr val="EDAB0C"/>
                 </a:solidFill>
@@ -11750,7 +11750,7 @@
               <a:t>■  </a:t>
             </a:r>
             <a:r>
-              <a:rPr sz="1800" b="1" i="0">
+              <a:rPr sz="2400" b="1" i="0">
                 <a:solidFill>
                   <a:srgbClr val="2A2929"/>
                 </a:solidFill>
@@ -11772,7 +11772,7 @@
               </a:spcAft>
             </a:pPr>
             <a:r>
-              <a:rPr sz="1500" b="0" i="0">
+              <a:rPr sz="2100" b="0" i="0">
                 <a:solidFill>
                   <a:srgbClr val="7A7A7A"/>
                 </a:solidFill>
@@ -11781,7 +11781,7 @@
               <a:t>–  </a:t>
             </a:r>
             <a:r>
-              <a:rPr sz="1500" b="0" i="0">
+              <a:rPr sz="2100" b="0" i="0">
                 <a:solidFill>
                   <a:srgbClr val="2A2929"/>
                 </a:solidFill>
@@ -11803,7 +11803,7 @@
               </a:spcAft>
             </a:pPr>
             <a:r>
-              <a:rPr sz="1800" b="1" i="0">
+              <a:rPr sz="2400" b="1" i="0">
                 <a:solidFill>
                   <a:srgbClr val="92268F"/>
                 </a:solidFill>
@@ -11812,7 +11812,7 @@
               <a:t>■  </a:t>
             </a:r>
             <a:r>
-              <a:rPr sz="1800" b="1" i="0">
+              <a:rPr sz="2400" b="1" i="0">
                 <a:solidFill>
                   <a:srgbClr val="92268F"/>
                 </a:solidFill>
@@ -11979,8 +11979,8 @@
         </p:nvSpPr>
         <p:spPr>
           <a:xfrm>
-            <a:off x="640080" y="502920"/>
-            <a:ext cx="10881360" cy="1005840"/>
+            <a:off x="640080" y="457200"/>
+            <a:ext cx="10881360" cy="960120"/>
           </a:xfrm>
           <a:prstGeom prst="rect">
             <a:avLst/>
@@ -11994,7 +11994,7 @@
           <a:lstStyle/>
           <a:p>
             <a:r>
-              <a:rPr sz="3000" b="1" i="0">
+              <a:rPr sz="2800" b="1" i="0">
                 <a:solidFill>
                   <a:srgbClr val="2A2929"/>
                 </a:solidFill>
@@ -12029,7 +12029,7 @@
         </p:nvSpPr>
         <p:spPr>
           <a:xfrm>
-            <a:off x="658368" y="1481328"/>
+            <a:off x="658368" y="1371600"/>
             <a:ext cx="1463040" cy="50800"/>
           </a:xfrm>
           <a:prstGeom prst="rect">
@@ -12073,8 +12073,8 @@
         </p:nvSpPr>
         <p:spPr>
           <a:xfrm>
-            <a:off x="658368" y="1783080"/>
-            <a:ext cx="10881360" cy="4389120"/>
+            <a:off x="658368" y="1691640"/>
+            <a:ext cx="10881360" cy="4480560"/>
           </a:xfrm>
           <a:prstGeom prst="rect">
             <a:avLst/>
@@ -12082,7 +12082,7 @@
           <a:noFill/>
         </p:spPr>
         <p:txBody>
-          <a:bodyPr wrap="square" anchor="t" lIns="0" rIns="0" tIns="0" bIns="0">
+          <a:bodyPr wrap="square" anchor="ctr" lIns="0" rIns="0" tIns="0" bIns="0">
             <a:spAutoFit/>
           </a:bodyPr>
           <a:lstStyle/>
@@ -12099,7 +12099,7 @@
               </a:spcAft>
             </a:pPr>
             <a:r>
-              <a:rPr sz="1800" b="1" i="0">
+              <a:rPr sz="2400" b="1" i="0">
                 <a:solidFill>
                   <a:srgbClr val="EDAB0C"/>
                 </a:solidFill>
@@ -12108,7 +12108,7 @@
               <a:t>■  </a:t>
             </a:r>
             <a:r>
-              <a:rPr sz="1800" b="0" i="0">
+              <a:rPr sz="2400" b="0" i="0">
                 <a:solidFill>
                   <a:srgbClr val="2A2929"/>
                 </a:solidFill>
@@ -12130,7 +12130,7 @@
               </a:spcAft>
             </a:pPr>
             <a:r>
-              <a:rPr sz="1800" b="1" i="0">
+              <a:rPr sz="2400" b="1" i="0">
                 <a:solidFill>
                   <a:srgbClr val="EDAB0C"/>
                 </a:solidFill>
@@ -12139,7 +12139,7 @@
               <a:t>■  </a:t>
             </a:r>
             <a:r>
-              <a:rPr sz="1800" b="0" i="0">
+              <a:rPr sz="2400" b="0" i="0">
                 <a:solidFill>
                   <a:srgbClr val="2A2929"/>
                 </a:solidFill>
@@ -12161,7 +12161,7 @@
               </a:spcAft>
             </a:pPr>
             <a:r>
-              <a:rPr sz="1800" b="1" i="0">
+              <a:rPr sz="2400" b="1" i="0">
                 <a:solidFill>
                   <a:srgbClr val="EDAB0C"/>
                 </a:solidFill>
@@ -12170,7 +12170,7 @@
               <a:t>■  </a:t>
             </a:r>
             <a:r>
-              <a:rPr sz="1800" b="0" i="0">
+              <a:rPr sz="2400" b="0" i="0">
                 <a:solidFill>
                   <a:srgbClr val="2A2929"/>
                 </a:solidFill>
@@ -12192,7 +12192,7 @@
               </a:spcAft>
             </a:pPr>
             <a:r>
-              <a:rPr sz="1500" b="0" i="0">
+              <a:rPr sz="2100" b="0" i="0">
                 <a:solidFill>
                   <a:srgbClr val="7A7A7A"/>
                 </a:solidFill>
@@ -12201,7 +12201,7 @@
               <a:t>–  </a:t>
             </a:r>
             <a:r>
-              <a:rPr sz="1500" b="0" i="0">
+              <a:rPr sz="2100" b="0" i="0">
                 <a:solidFill>
                   <a:srgbClr val="2A2929"/>
                 </a:solidFill>
@@ -12223,7 +12223,7 @@
               </a:spcAft>
             </a:pPr>
             <a:r>
-              <a:rPr sz="1500" b="0" i="0">
+              <a:rPr sz="2100" b="0" i="0">
                 <a:solidFill>
                   <a:srgbClr val="7A7A7A"/>
                 </a:solidFill>
@@ -12232,7 +12232,7 @@
               <a:t>–  </a:t>
             </a:r>
             <a:r>
-              <a:rPr sz="1500" b="0" i="0">
+              <a:rPr sz="2100" b="0" i="0">
                 <a:solidFill>
                   <a:srgbClr val="2A2929"/>
                 </a:solidFill>
@@ -12399,8 +12399,8 @@
         </p:nvSpPr>
         <p:spPr>
           <a:xfrm>
-            <a:off x="640080" y="502920"/>
-            <a:ext cx="10881360" cy="1005840"/>
+            <a:off x="640080" y="457200"/>
+            <a:ext cx="10881360" cy="960120"/>
           </a:xfrm>
           <a:prstGeom prst="rect">
             <a:avLst/>
@@ -12414,7 +12414,7 @@
           <a:lstStyle/>
           <a:p>
             <a:r>
-              <a:rPr sz="3000" b="1" i="0">
+              <a:rPr sz="2800" b="1" i="0">
                 <a:solidFill>
                   <a:srgbClr val="2A2929"/>
                 </a:solidFill>
@@ -12433,7 +12433,7 @@
         </p:nvSpPr>
         <p:spPr>
           <a:xfrm>
-            <a:off x="658368" y="1481328"/>
+            <a:off x="658368" y="1371600"/>
             <a:ext cx="1463040" cy="50800"/>
           </a:xfrm>
           <a:prstGeom prst="rect">
@@ -12477,8 +12477,8 @@
         </p:nvSpPr>
         <p:spPr>
           <a:xfrm>
-            <a:off x="658368" y="1783080"/>
-            <a:ext cx="10881360" cy="4389120"/>
+            <a:off x="658368" y="1691640"/>
+            <a:ext cx="10881360" cy="4480560"/>
           </a:xfrm>
           <a:prstGeom prst="rect">
             <a:avLst/>
@@ -12486,7 +12486,7 @@
           <a:noFill/>
         </p:spPr>
         <p:txBody>
-          <a:bodyPr wrap="square" anchor="t" lIns="0" rIns="0" tIns="0" bIns="0">
+          <a:bodyPr wrap="square" anchor="ctr" lIns="0" rIns="0" tIns="0" bIns="0">
             <a:spAutoFit/>
           </a:bodyPr>
           <a:lstStyle/>
@@ -12503,7 +12503,7 @@
               </a:spcAft>
             </a:pPr>
             <a:r>
-              <a:rPr sz="1800" b="1" i="0">
+              <a:rPr sz="2400" b="1" i="0">
                 <a:solidFill>
                   <a:srgbClr val="EDAB0C"/>
                 </a:solidFill>
@@ -12512,7 +12512,7 @@
               <a:t>■  </a:t>
             </a:r>
             <a:r>
-              <a:rPr sz="1800" b="0" i="0">
+              <a:rPr sz="2400" b="0" i="0">
                 <a:solidFill>
                   <a:srgbClr val="2A2929"/>
                 </a:solidFill>
@@ -12534,7 +12534,7 @@
               </a:spcAft>
             </a:pPr>
             <a:r>
-              <a:rPr sz="1800" b="1" i="0">
+              <a:rPr sz="2400" b="1" i="0">
                 <a:solidFill>
                   <a:srgbClr val="EDAB0C"/>
                 </a:solidFill>
@@ -12543,7 +12543,7 @@
               <a:t>■  </a:t>
             </a:r>
             <a:r>
-              <a:rPr sz="1800" b="0" i="0">
+              <a:rPr sz="2400" b="0" i="0">
                 <a:solidFill>
                   <a:srgbClr val="2A2929"/>
                 </a:solidFill>
@@ -12565,7 +12565,7 @@
               </a:spcAft>
             </a:pPr>
             <a:r>
-              <a:rPr sz="1800" b="1" i="0">
+              <a:rPr sz="2400" b="1" i="0">
                 <a:solidFill>
                   <a:srgbClr val="EDAB0C"/>
                 </a:solidFill>
@@ -12574,7 +12574,7 @@
               <a:t>■  </a:t>
             </a:r>
             <a:r>
-              <a:rPr sz="1800" b="0" i="0">
+              <a:rPr sz="2400" b="0" i="0">
                 <a:solidFill>
                   <a:srgbClr val="2A2929"/>
                 </a:solidFill>
@@ -12596,7 +12596,7 @@
               </a:spcAft>
             </a:pPr>
             <a:r>
-              <a:rPr sz="1800" b="1" i="0">
+              <a:rPr sz="2400" b="1" i="0">
                 <a:solidFill>
                   <a:srgbClr val="92268F"/>
                 </a:solidFill>
@@ -12605,7 +12605,7 @@
               <a:t>■  </a:t>
             </a:r>
             <a:r>
-              <a:rPr sz="1800" b="1" i="0">
+              <a:rPr sz="2400" b="1" i="0">
                 <a:solidFill>
                   <a:srgbClr val="92268F"/>
                 </a:solidFill>
@@ -12845,7 +12845,7 @@
           </a:fontRef>
         </p:style>
         <p:txBody>
-          <a:bodyPr rtlCol="0" anchor="ctr" wrap="none"/>
+          <a:bodyPr rtlCol="0" anchor="ctr"/>
           <a:lstStyle/>
           <a:p>
             <a:pPr algn="ctr"/>

</xml_diff>

<commit_message>
feat(cl1): teacher speaker notes across all 14 topics (232 notes)
Every teaching/activity/demo slide in CL1 now carries teacher notes in the
notes pane (Presenter View) — decks are teachable cold. Per topic a sibling
topicNN_notes.py holds {title: notes}, registered via register_notes(); the
builder attaches them by title. Type-aware: teaching = frame/walk-points/
misconception/question/UoC tie; demo = what-to-demonstrate/emphasise + WHERE TO
FIND the AWS recorded demo (deck·module·slide from the demos catalogue);
activity = facilitation script. Topic 06's inline notes folded into its module.
All 15 decks rebuilt; per-deck noted-slide counts match their dicts exactly.

Co-Authored-By: Claude Opus 4.8 (1M context) <noreply@anthropic.com>
</commit_message>
<xml_diff>
--- a/S1-CL1-Cloud-Design-Build/delivery/topic_02/Topic_02_Slides.pptx
+++ b/S1-CL1-Cloud-Design-Build/delivery/topic_02/Topic_02_Slides.pptx
@@ -7,27 +7,27 @@
   <p:sldIdLst>
     <p:sldId id="256" r:id="rId7"/>
     <p:sldId id="257" r:id="rId8"/>
-    <p:sldId id="258" r:id="rId9"/>
-    <p:sldId id="259" r:id="rId10"/>
-    <p:sldId id="260" r:id="rId11"/>
-    <p:sldId id="261" r:id="rId12"/>
-    <p:sldId id="262" r:id="rId13"/>
-    <p:sldId id="263" r:id="rId14"/>
-    <p:sldId id="264" r:id="rId15"/>
-    <p:sldId id="265" r:id="rId16"/>
-    <p:sldId id="266" r:id="rId17"/>
-    <p:sldId id="267" r:id="rId18"/>
-    <p:sldId id="268" r:id="rId19"/>
-    <p:sldId id="269" r:id="rId20"/>
-    <p:sldId id="270" r:id="rId21"/>
-    <p:sldId id="271" r:id="rId22"/>
-    <p:sldId id="272" r:id="rId23"/>
-    <p:sldId id="273" r:id="rId24"/>
-    <p:sldId id="274" r:id="rId25"/>
-    <p:sldId id="275" r:id="rId26"/>
-    <p:sldId id="276" r:id="rId27"/>
-    <p:sldId id="277" r:id="rId28"/>
-    <p:sldId id="278" r:id="rId29"/>
+    <p:sldId id="258" r:id="rId10"/>
+    <p:sldId id="259" r:id="rId11"/>
+    <p:sldId id="260" r:id="rId12"/>
+    <p:sldId id="261" r:id="rId13"/>
+    <p:sldId id="262" r:id="rId14"/>
+    <p:sldId id="263" r:id="rId15"/>
+    <p:sldId id="264" r:id="rId16"/>
+    <p:sldId id="265" r:id="rId17"/>
+    <p:sldId id="266" r:id="rId18"/>
+    <p:sldId id="267" r:id="rId19"/>
+    <p:sldId id="268" r:id="rId20"/>
+    <p:sldId id="269" r:id="rId21"/>
+    <p:sldId id="270" r:id="rId22"/>
+    <p:sldId id="271" r:id="rId23"/>
+    <p:sldId id="272" r:id="rId24"/>
+    <p:sldId id="273" r:id="rId25"/>
+    <p:sldId id="274" r:id="rId26"/>
+    <p:sldId id="275" r:id="rId27"/>
+    <p:sldId id="276" r:id="rId28"/>
+    <p:sldId id="277" r:id="rId29"/>
+    <p:sldId id="278" r:id="rId30"/>
   </p:sldIdLst>
   <p:sldSz cx="12191695" cy="6858000" type="screen4x3"/>
   <p:notesSz cx="6858000" cy="9144000"/>
@@ -127,6 +127,2081 @@
     </a:lvl9pPr>
   </p:defaultTextStyle>
 </p:presentation>
+</file>
+
+<file path=ppt/notesMasters/notesMaster1.xml><?xml version="1.0" encoding="utf-8"?>
+<p:notesMaster xmlns:a="http://schemas.openxmlformats.org/drawingml/2006/main" xmlns:p="http://schemas.openxmlformats.org/presentationml/2006/main" xmlns:r="http://schemas.openxmlformats.org/officeDocument/2006/relationships">
+  <p:cSld>
+    <p:bg>
+      <p:bgRef idx="1001">
+        <a:schemeClr val="bg1"/>
+      </p:bgRef>
+    </p:bg>
+    <p:spTree>
+      <p:nvGrpSpPr>
+        <p:cNvPr id="1" name=""/>
+        <p:cNvGrpSpPr/>
+        <p:nvPr/>
+      </p:nvGrpSpPr>
+      <p:grpSpPr>
+        <a:xfrm>
+          <a:off x="0" y="0"/>
+          <a:ext cx="0" cy="0"/>
+          <a:chOff x="0" y="0"/>
+          <a:chExt cx="0" cy="0"/>
+        </a:xfrm>
+      </p:grpSpPr>
+      <p:sp>
+        <p:nvSpPr>
+          <p:cNvPr id="2" name="Header Placeholder 1"/>
+          <p:cNvSpPr>
+            <a:spLocks noGrp="1"/>
+          </p:cNvSpPr>
+          <p:nvPr>
+            <p:ph type="hdr" sz="quarter"/>
+          </p:nvPr>
+        </p:nvSpPr>
+        <p:spPr>
+          <a:xfrm>
+            <a:off x="0" y="0"/>
+            <a:ext cx="2971800" cy="457200"/>
+          </a:xfrm>
+          <a:prstGeom prst="rect">
+            <a:avLst/>
+          </a:prstGeom>
+        </p:spPr>
+        <p:txBody>
+          <a:bodyPr vert="horz" lIns="91440" tIns="45720" rIns="91440" bIns="45720" rtlCol="0"/>
+          <a:lstStyle>
+            <a:lvl1pPr algn="l">
+              <a:defRPr sz="1200"/>
+            </a:lvl1pPr>
+          </a:lstStyle>
+          <a:p>
+            <a:endParaRPr lang="en-US"/>
+          </a:p>
+        </p:txBody>
+      </p:sp>
+      <p:sp>
+        <p:nvSpPr>
+          <p:cNvPr id="3" name="Date Placeholder 2"/>
+          <p:cNvSpPr>
+            <a:spLocks noGrp="1"/>
+          </p:cNvSpPr>
+          <p:nvPr>
+            <p:ph type="dt" idx="1"/>
+          </p:nvPr>
+        </p:nvSpPr>
+        <p:spPr>
+          <a:xfrm>
+            <a:off x="3884613" y="0"/>
+            <a:ext cx="2971800" cy="457200"/>
+          </a:xfrm>
+          <a:prstGeom prst="rect">
+            <a:avLst/>
+          </a:prstGeom>
+        </p:spPr>
+        <p:txBody>
+          <a:bodyPr vert="horz" lIns="91440" tIns="45720" rIns="91440" bIns="45720" rtlCol="0"/>
+          <a:lstStyle>
+            <a:lvl1pPr algn="r">
+              <a:defRPr sz="1200"/>
+            </a:lvl1pPr>
+          </a:lstStyle>
+          <a:p>
+            <a:fld id="{0F89C1C7-3DCD-1040-A9CF-14679D8B5DDD}" type="datetimeFigureOut">
+              <a:rPr lang="en-US" smtClean="0"/>
+              <a:t>10/17/16</a:t>
+            </a:fld>
+            <a:endParaRPr lang="en-US"/>
+          </a:p>
+        </p:txBody>
+      </p:sp>
+      <p:sp>
+        <p:nvSpPr>
+          <p:cNvPr id="4" name="Slide Image Placeholder 3"/>
+          <p:cNvSpPr>
+            <a:spLocks noGrp="1" noRot="1" noChangeAspect="1"/>
+          </p:cNvSpPr>
+          <p:nvPr>
+            <p:ph type="sldImg" idx="2"/>
+          </p:nvPr>
+        </p:nvSpPr>
+        <p:spPr>
+          <a:xfrm>
+            <a:off x="1143000" y="685800"/>
+            <a:ext cx="4572000" cy="3429000"/>
+          </a:xfrm>
+          <a:prstGeom prst="rect">
+            <a:avLst/>
+          </a:prstGeom>
+          <a:noFill/>
+          <a:ln w="12700">
+            <a:solidFill>
+              <a:prstClr val="black"/>
+            </a:solidFill>
+          </a:ln>
+        </p:spPr>
+        <p:txBody>
+          <a:bodyPr vert="horz" lIns="91440" tIns="45720" rIns="91440" bIns="45720" rtlCol="0" anchor="ctr"/>
+          <a:lstStyle/>
+          <a:p>
+            <a:endParaRPr lang="en-US"/>
+          </a:p>
+        </p:txBody>
+      </p:sp>
+      <p:sp>
+        <p:nvSpPr>
+          <p:cNvPr id="5" name="Notes Placeholder 4"/>
+          <p:cNvSpPr>
+            <a:spLocks noGrp="1"/>
+          </p:cNvSpPr>
+          <p:nvPr>
+            <p:ph type="body" sz="quarter" idx="3"/>
+          </p:nvPr>
+        </p:nvSpPr>
+        <p:spPr>
+          <a:xfrm>
+            <a:off x="685800" y="4343400"/>
+            <a:ext cx="5486400" cy="4114800"/>
+          </a:xfrm>
+          <a:prstGeom prst="rect">
+            <a:avLst/>
+          </a:prstGeom>
+        </p:spPr>
+        <p:txBody>
+          <a:bodyPr vert="horz" lIns="91440" tIns="45720" rIns="91440" bIns="45720" rtlCol="0"/>
+          <a:lstStyle/>
+          <a:p>
+            <a:pPr lvl="0"/>
+            <a:r>
+              <a:rPr lang="en-US" smtClean="0"/>
+              <a:t>Click to edit Master text styles</a:t>
+            </a:r>
+          </a:p>
+          <a:p>
+            <a:pPr lvl="1"/>
+            <a:r>
+              <a:rPr lang="en-US" smtClean="0"/>
+              <a:t>Second level</a:t>
+            </a:r>
+          </a:p>
+          <a:p>
+            <a:pPr lvl="2"/>
+            <a:r>
+              <a:rPr lang="en-US" smtClean="0"/>
+              <a:t>Third level</a:t>
+            </a:r>
+          </a:p>
+          <a:p>
+            <a:pPr lvl="3"/>
+            <a:r>
+              <a:rPr lang="en-US" smtClean="0"/>
+              <a:t>Fourth level</a:t>
+            </a:r>
+          </a:p>
+          <a:p>
+            <a:pPr lvl="4"/>
+            <a:r>
+              <a:rPr lang="en-US" smtClean="0"/>
+              <a:t>Fifth level</a:t>
+            </a:r>
+            <a:endParaRPr lang="en-US"/>
+          </a:p>
+        </p:txBody>
+      </p:sp>
+      <p:sp>
+        <p:nvSpPr>
+          <p:cNvPr id="6" name="Footer Placeholder 5"/>
+          <p:cNvSpPr>
+            <a:spLocks noGrp="1"/>
+          </p:cNvSpPr>
+          <p:nvPr>
+            <p:ph type="ftr" sz="quarter" idx="4"/>
+          </p:nvPr>
+        </p:nvSpPr>
+        <p:spPr>
+          <a:xfrm>
+            <a:off x="0" y="8685213"/>
+            <a:ext cx="2971800" cy="457200"/>
+          </a:xfrm>
+          <a:prstGeom prst="rect">
+            <a:avLst/>
+          </a:prstGeom>
+        </p:spPr>
+        <p:txBody>
+          <a:bodyPr vert="horz" lIns="91440" tIns="45720" rIns="91440" bIns="45720" rtlCol="0" anchor="b"/>
+          <a:lstStyle>
+            <a:lvl1pPr algn="l">
+              <a:defRPr sz="1200"/>
+            </a:lvl1pPr>
+          </a:lstStyle>
+          <a:p>
+            <a:endParaRPr lang="en-US"/>
+          </a:p>
+        </p:txBody>
+      </p:sp>
+      <p:sp>
+        <p:nvSpPr>
+          <p:cNvPr id="7" name="Slide Number Placeholder 6"/>
+          <p:cNvSpPr>
+            <a:spLocks noGrp="1"/>
+          </p:cNvSpPr>
+          <p:nvPr>
+            <p:ph type="sldNum" sz="quarter" idx="5"/>
+          </p:nvPr>
+        </p:nvSpPr>
+        <p:spPr>
+          <a:xfrm>
+            <a:off x="3884613" y="8685213"/>
+            <a:ext cx="2971800" cy="457200"/>
+          </a:xfrm>
+          <a:prstGeom prst="rect">
+            <a:avLst/>
+          </a:prstGeom>
+        </p:spPr>
+        <p:txBody>
+          <a:bodyPr vert="horz" lIns="91440" tIns="45720" rIns="91440" bIns="45720" rtlCol="0" anchor="b"/>
+          <a:lstStyle>
+            <a:lvl1pPr algn="r">
+              <a:defRPr sz="1200"/>
+            </a:lvl1pPr>
+          </a:lstStyle>
+          <a:p>
+            <a:fld id="{BB5E49A5-4136-284D-997B-48E1D791AD67}" type="slidenum">
+              <a:rPr lang="en-US" smtClean="0"/>
+              <a:t>‹#›</a:t>
+            </a:fld>
+            <a:endParaRPr lang="en-US"/>
+          </a:p>
+        </p:txBody>
+      </p:sp>
+    </p:spTree>
+    <p:extLst>
+      <p:ext uri="{BB962C8B-B14F-4D97-AF65-F5344CB8AC3E}">
+        <p14:creationId xmlns:p14="http://schemas.microsoft.com/office/powerpoint/2010/main" val="2623252185"/>
+      </p:ext>
+    </p:extLst>
+  </p:cSld>
+  <p:clrMap bg1="lt1" tx1="dk1" bg2="lt2" tx2="dk2" accent1="accent1" accent2="accent2" accent3="accent3" accent4="accent4" accent5="accent5" accent6="accent6" hlink="hlink" folHlink="folHlink"/>
+  <p:notesStyle>
+    <a:lvl1pPr marL="0" algn="l" defTabSz="457200" rtl="0" eaLnBrk="1" latinLnBrk="0" hangingPunct="1">
+      <a:defRPr sz="1200" kern="1200">
+        <a:solidFill>
+          <a:schemeClr val="tx1"/>
+        </a:solidFill>
+        <a:latin typeface="+mn-lt"/>
+        <a:ea typeface="+mn-ea"/>
+        <a:cs typeface="+mn-cs"/>
+      </a:defRPr>
+    </a:lvl1pPr>
+    <a:lvl2pPr marL="457200" algn="l" defTabSz="457200" rtl="0" eaLnBrk="1" latinLnBrk="0" hangingPunct="1">
+      <a:defRPr sz="1200" kern="1200">
+        <a:solidFill>
+          <a:schemeClr val="tx1"/>
+        </a:solidFill>
+        <a:latin typeface="+mn-lt"/>
+        <a:ea typeface="+mn-ea"/>
+        <a:cs typeface="+mn-cs"/>
+      </a:defRPr>
+    </a:lvl2pPr>
+    <a:lvl3pPr marL="914400" algn="l" defTabSz="457200" rtl="0" eaLnBrk="1" latinLnBrk="0" hangingPunct="1">
+      <a:defRPr sz="1200" kern="1200">
+        <a:solidFill>
+          <a:schemeClr val="tx1"/>
+        </a:solidFill>
+        <a:latin typeface="+mn-lt"/>
+        <a:ea typeface="+mn-ea"/>
+        <a:cs typeface="+mn-cs"/>
+      </a:defRPr>
+    </a:lvl3pPr>
+    <a:lvl4pPr marL="1371600" algn="l" defTabSz="457200" rtl="0" eaLnBrk="1" latinLnBrk="0" hangingPunct="1">
+      <a:defRPr sz="1200" kern="1200">
+        <a:solidFill>
+          <a:schemeClr val="tx1"/>
+        </a:solidFill>
+        <a:latin typeface="+mn-lt"/>
+        <a:ea typeface="+mn-ea"/>
+        <a:cs typeface="+mn-cs"/>
+      </a:defRPr>
+    </a:lvl4pPr>
+    <a:lvl5pPr marL="1828800" algn="l" defTabSz="457200" rtl="0" eaLnBrk="1" latinLnBrk="0" hangingPunct="1">
+      <a:defRPr sz="1200" kern="1200">
+        <a:solidFill>
+          <a:schemeClr val="tx1"/>
+        </a:solidFill>
+        <a:latin typeface="+mn-lt"/>
+        <a:ea typeface="+mn-ea"/>
+        <a:cs typeface="+mn-cs"/>
+      </a:defRPr>
+    </a:lvl5pPr>
+    <a:lvl6pPr marL="2286000" algn="l" defTabSz="457200" rtl="0" eaLnBrk="1" latinLnBrk="0" hangingPunct="1">
+      <a:defRPr sz="1200" kern="1200">
+        <a:solidFill>
+          <a:schemeClr val="tx1"/>
+        </a:solidFill>
+        <a:latin typeface="+mn-lt"/>
+        <a:ea typeface="+mn-ea"/>
+        <a:cs typeface="+mn-cs"/>
+      </a:defRPr>
+    </a:lvl6pPr>
+    <a:lvl7pPr marL="2743200" algn="l" defTabSz="457200" rtl="0" eaLnBrk="1" latinLnBrk="0" hangingPunct="1">
+      <a:defRPr sz="1200" kern="1200">
+        <a:solidFill>
+          <a:schemeClr val="tx1"/>
+        </a:solidFill>
+        <a:latin typeface="+mn-lt"/>
+        <a:ea typeface="+mn-ea"/>
+        <a:cs typeface="+mn-cs"/>
+      </a:defRPr>
+    </a:lvl7pPr>
+    <a:lvl8pPr marL="3200400" algn="l" defTabSz="457200" rtl="0" eaLnBrk="1" latinLnBrk="0" hangingPunct="1">
+      <a:defRPr sz="1200" kern="1200">
+        <a:solidFill>
+          <a:schemeClr val="tx1"/>
+        </a:solidFill>
+        <a:latin typeface="+mn-lt"/>
+        <a:ea typeface="+mn-ea"/>
+        <a:cs typeface="+mn-cs"/>
+      </a:defRPr>
+    </a:lvl8pPr>
+    <a:lvl9pPr marL="3657600" algn="l" defTabSz="457200" rtl="0" eaLnBrk="1" latinLnBrk="0" hangingPunct="1">
+      <a:defRPr sz="1200" kern="1200">
+        <a:solidFill>
+          <a:schemeClr val="tx1"/>
+        </a:solidFill>
+        <a:latin typeface="+mn-lt"/>
+        <a:ea typeface="+mn-ea"/>
+        <a:cs typeface="+mn-cs"/>
+      </a:defRPr>
+    </a:lvl9pPr>
+  </p:notesStyle>
+</p:notesMaster>
+</file>
+
+<file path=ppt/notesSlides/notesSlide1.xml><?xml version="1.0" encoding="utf-8"?>
+<p:notes xmlns:a="http://schemas.openxmlformats.org/drawingml/2006/main" xmlns:p="http://schemas.openxmlformats.org/presentationml/2006/main" xmlns:r="http://schemas.openxmlformats.org/officeDocument/2006/relationships">
+  <p:cSld>
+    <p:spTree>
+      <p:nvGrpSpPr>
+        <p:cNvPr id="1" name=""/>
+        <p:cNvGrpSpPr/>
+        <p:nvPr/>
+      </p:nvGrpSpPr>
+      <p:grpSpPr>
+        <a:xfrm>
+          <a:off x="0" y="0"/>
+          <a:ext cx="0" cy="0"/>
+          <a:chOff x="0" y="0"/>
+          <a:chExt cx="0" cy="0"/>
+        </a:xfrm>
+      </p:grpSpPr>
+      <p:sp>
+        <p:nvSpPr>
+          <p:cNvPr id="2" name="Slide Image Placeholder 1"/>
+          <p:cNvSpPr>
+            <a:spLocks noGrp="1"/>
+          </p:cNvSpPr>
+          <p:nvPr>
+            <p:ph type="sldImg" idx="2"/>
+          </p:nvPr>
+        </p:nvSpPr>
+        <p:spPr/>
+      </p:sp>
+      <p:sp>
+        <p:nvSpPr>
+          <p:cNvPr id="3" name="Notes Placeholder 2"/>
+          <p:cNvSpPr>
+            <a:spLocks noGrp="1"/>
+          </p:cNvSpPr>
+          <p:nvPr>
+            <p:ph type="body" idx="3" sz="quarter"/>
+          </p:nvPr>
+        </p:nvSpPr>
+        <p:spPr/>
+        <p:txBody>
+          <a:bodyPr/>
+          <a:lstStyle/>
+          <a:p>
+            <a:r>
+              <a:t>Frame the whole Topic as the pivot from Topic 1: they can speak cloud now — today they DIAGNOSE.</a:t>
+            </a:r>
+          </a:p>
+          <a:p>
+            <a:r>
+              <a:t>Set expectations, don't yet teach a section.</a:t>
+            </a:r>
+          </a:p>
+          <a:p>
+            <a:r>
+              <a:t>• First bullet: literacy was the warm-up; the real consulting job is working out where the</a:t>
+            </a:r>
+          </a:p>
+          <a:p>
+            <a:r>
+              <a:t>  organisation is, where it needs to be, and the gap between. No solutions yet.</a:t>
+            </a:r>
+          </a:p>
+          <a:p>
+            <a:r>
+              <a:t>• Second bullet: that's the whole job of a case for change — locate the client on the map before</a:t>
+            </a:r>
+          </a:p>
+          <a:p>
+            <a:r>
+              <a:t>  you plot a route.</a:t>
+            </a:r>
+          </a:p>
+          <a:p>
+            <a:r>
+              <a:t>• Third bullet (bolded): the three moves — align to strategy → describe the current state → expose</a:t>
+            </a:r>
+          </a:p>
+          <a:p>
+            <a:r>
+              <a:t>  the gaps. Say them in that order; each depends on the one before.</a:t>
+            </a:r>
+          </a:p>
+          <a:p>
+            <a:r>
+              <a:t>• Fourth bullet: these three become the OPENING SECTIONS of the business case (AT1 §3–§5). What</a:t>
+            </a:r>
+          </a:p>
+          <a:p>
+            <a:r>
+              <a:t>  they build today is directly the front half of the AT1 deliverable.</a:t>
+            </a:r>
+          </a:p>
+          <a:p>
+            <a:r>
+              <a:t>Misconception to pre-empt: "we're picking a cloud solution today." No — diagnosis comes before</a:t>
+            </a:r>
+          </a:p>
+          <a:p>
+            <a:r>
+              <a:t>prescription; solutions are Topic 3. Manage the student who jumps straight to "move it to AWS".</a:t>
+            </a:r>
+          </a:p>
+          <a:p>
+            <a:r>
+              <a:t>Question to pose: "Before you can recommend a fix, what three things must you establish about the</a:t>
+            </a:r>
+          </a:p>
+          <a:p>
+            <a:r>
+              <a:t>client?" — draws out strategy / current state / gap.</a:t>
+            </a:r>
+          </a:p>
+          <a:p>
+            <a:r>
+              <a:t>UoC/AT1 tie: this Topic develops PC 1.1–1.3 and PE 1–3; the output is AT1 Part A §3–§5.</a:t>
+            </a:r>
+          </a:p>
+        </p:txBody>
+      </p:sp>
+      <p:sp>
+        <p:nvSpPr>
+          <p:cNvPr id="4" name="Slide Number Placeholder 3"/>
+          <p:cNvSpPr>
+            <a:spLocks noGrp="1"/>
+          </p:cNvSpPr>
+          <p:nvPr>
+            <p:ph type="sldNum" idx="5" sz="quarter"/>
+          </p:nvPr>
+        </p:nvSpPr>
+        <p:spPr/>
+      </p:sp>
+    </p:spTree>
+  </p:cSld>
+  <p:clrMapOvr>
+    <a:masterClrMapping/>
+  </p:clrMapOvr>
+</p:notes>
+</file>
+
+<file path=ppt/notesSlides/notesSlide10.xml><?xml version="1.0" encoding="utf-8"?>
+<p:notes xmlns:a="http://schemas.openxmlformats.org/drawingml/2006/main" xmlns:p="http://schemas.openxmlformats.org/presentationml/2006/main" xmlns:r="http://schemas.openxmlformats.org/officeDocument/2006/relationships">
+  <p:cSld>
+    <p:spTree>
+      <p:nvGrpSpPr>
+        <p:cNvPr id="1" name=""/>
+        <p:cNvGrpSpPr/>
+        <p:nvPr/>
+      </p:nvGrpSpPr>
+      <p:grpSpPr>
+        <a:xfrm>
+          <a:off x="0" y="0"/>
+          <a:ext cx="0" cy="0"/>
+          <a:chOff x="0" y="0"/>
+          <a:chExt cx="0" cy="0"/>
+        </a:xfrm>
+      </p:grpSpPr>
+      <p:sp>
+        <p:nvSpPr>
+          <p:cNvPr id="2" name="Slide Image Placeholder 1"/>
+          <p:cNvSpPr>
+            <a:spLocks noGrp="1"/>
+          </p:cNvSpPr>
+          <p:nvPr>
+            <p:ph type="sldImg" idx="2"/>
+          </p:nvPr>
+        </p:nvSpPr>
+        <p:spPr/>
+      </p:sp>
+      <p:sp>
+        <p:nvSpPr>
+          <p:cNvPr id="3" name="Notes Placeholder 2"/>
+          <p:cNvSpPr>
+            <a:spLocks noGrp="1"/>
+          </p:cNvSpPr>
+          <p:nvPr>
+            <p:ph type="body" idx="3" sz="quarter"/>
+          </p:nvPr>
+        </p:nvSpPr>
+        <p:spPr/>
+        <p:txBody>
+          <a:bodyPr/>
+          <a:lstStyle/>
+          <a:p>
+            <a:r>
+              <a:t>The three-step method that turns source docs into a synthesised current state — teach it as a</a:t>
+            </a:r>
+          </a:p>
+          <a:p>
+            <a:r>
+              <a:t>repeatable procedure they'll run in the activity next.</a:t>
+            </a:r>
+          </a:p>
+          <a:p>
+            <a:r>
+              <a:t>• Step 1: read the source docs — environment overview, server/app specs, consultation notes.</a:t>
+            </a:r>
+          </a:p>
+          <a:p>
+            <a:r>
+              <a:t>• Step 2: for EACH fact ask "does this affect the renew-vs-migrate decision?" If no, cut it (this is</a:t>
+            </a:r>
+          </a:p>
+          <a:p>
+            <a:r>
+              <a:t>  the relevance filter applied).</a:t>
+            </a:r>
+          </a:p>
+          <a:p>
+            <a:r>
+              <a:t>• Step 3: re-state what's left in PLAIN LANGUAGE, grouped — platform / workload / dependencies /</a:t>
+            </a:r>
+          </a:p>
+          <a:p>
+            <a:r>
+              <a:t>  condition-risk. Grouping is what makes it read as synthesis, not a list.</a:t>
+            </a:r>
+          </a:p>
+          <a:p>
+            <a:r>
+              <a:t>• Aim ~half a page, no copy-paste (bolded).</a:t>
+            </a:r>
+          </a:p>
+          <a:p>
+            <a:r>
+              <a:t>Misconception to pre-empt: "re-state = reword each sentence." No — you regroup and compress across</a:t>
+            </a:r>
+          </a:p>
+          <a:p>
+            <a:r>
+              <a:t>documents; the output is shorter and organised by theme, not a paraphrase of every line.</a:t>
+            </a:r>
+          </a:p>
+          <a:p>
+            <a:r>
+              <a:t>Question to pose: "You've got five source docs — what's the first question you ask of every fact in</a:t>
+            </a:r>
+          </a:p>
+          <a:p>
+            <a:r>
+              <a:t>them?" ("does it affect the decision?").</a:t>
+            </a:r>
+          </a:p>
+          <a:p>
+            <a:r>
+              <a:t>UoC/AT1 tie: PC 1.2 / PE 2 → AT1 §4; this procedure is exactly how a strong A2 gets written.</a:t>
+            </a:r>
+          </a:p>
+        </p:txBody>
+      </p:sp>
+      <p:sp>
+        <p:nvSpPr>
+          <p:cNvPr id="4" name="Slide Number Placeholder 3"/>
+          <p:cNvSpPr>
+            <a:spLocks noGrp="1"/>
+          </p:cNvSpPr>
+          <p:nvPr>
+            <p:ph type="sldNum" idx="5" sz="quarter"/>
+          </p:nvPr>
+        </p:nvSpPr>
+        <p:spPr/>
+      </p:sp>
+    </p:spTree>
+  </p:cSld>
+  <p:clrMapOvr>
+    <a:masterClrMapping/>
+  </p:clrMapOvr>
+</p:notes>
+</file>
+
+<file path=ppt/notesSlides/notesSlide11.xml><?xml version="1.0" encoding="utf-8"?>
+<p:notes xmlns:a="http://schemas.openxmlformats.org/drawingml/2006/main" xmlns:p="http://schemas.openxmlformats.org/presentationml/2006/main" xmlns:r="http://schemas.openxmlformats.org/officeDocument/2006/relationships">
+  <p:cSld>
+    <p:spTree>
+      <p:nvGrpSpPr>
+        <p:cNvPr id="1" name=""/>
+        <p:cNvGrpSpPr/>
+        <p:nvPr/>
+      </p:nvGrpSpPr>
+      <p:grpSpPr>
+        <a:xfrm>
+          <a:off x="0" y="0"/>
+          <a:ext cx="0" cy="0"/>
+          <a:chOff x="0" y="0"/>
+          <a:chExt cx="0" cy="0"/>
+        </a:xfrm>
+      </p:grpSpPr>
+      <p:sp>
+        <p:nvSpPr>
+          <p:cNvPr id="2" name="Slide Image Placeholder 1"/>
+          <p:cNvSpPr>
+            <a:spLocks noGrp="1"/>
+          </p:cNvSpPr>
+          <p:nvPr>
+            <p:ph type="sldImg" idx="2"/>
+          </p:nvPr>
+        </p:nvSpPr>
+        <p:spPr/>
+      </p:sp>
+      <p:sp>
+        <p:nvSpPr>
+          <p:cNvPr id="3" name="Notes Placeholder 2"/>
+          <p:cNvSpPr>
+            <a:spLocks noGrp="1"/>
+          </p:cNvSpPr>
+          <p:nvPr>
+            <p:ph type="body" idx="3" sz="quarter"/>
+          </p:nvPr>
+        </p:nvSpPr>
+        <p:spPr/>
+        <p:txBody>
+          <a:bodyPr/>
+          <a:lstStyle/>
+          <a:p>
+            <a:r>
+              <a:t>Facilitation — the Section 2 practice; students draft §4 of the practice business case (Ledgerline),</a:t>
+            </a:r>
+          </a:p>
+          <a:p>
+            <a:r>
+              <a:t>mirroring AT1 §4 on a different system.</a:t>
+            </a:r>
+          </a:p>
+          <a:p>
+            <a:r>
+              <a:t>Tell students: "In your working copy of the Business Case, add the Current State section for the</a:t>
+            </a:r>
+          </a:p>
+          <a:p>
+            <a:r>
+              <a:t>Accounting System (Ledgerline). Synthesise — in your own words, material facts only."</a:t>
+            </a:r>
+          </a:p>
+          <a:p>
+            <a:r>
+              <a:t>Steps (put on the board):</a:t>
+            </a:r>
+          </a:p>
+          <a:p>
+            <a:r>
+              <a:t>1. Use the Accounting application spec, server specs, operational costing, the ICT Environment</a:t>
+            </a:r>
+          </a:p>
+          <a:p>
+            <a:r>
+              <a:t>   Overview, and the consultation notes on the scenario intranet.</a:t>
+            </a:r>
+          </a:p>
+          <a:p>
+            <a:r>
+              <a:t>2. Cover: platform &amp; stack · workload (incl. month-end / EOFY peaks) · integrations (AD, O365, LMS</a:t>
+            </a:r>
+          </a:p>
+          <a:p>
+            <a:r>
+              <a:t>   fee-status, payroll, banking) · condition &amp; constraints.</a:t>
+            </a:r>
+          </a:p>
+          <a:p>
+            <a:r>
+              <a:t>3. Run the relevance filter on every fact; group what survives.</a:t>
+            </a:r>
+          </a:p>
+          <a:p>
+            <a:r>
+              <a:t>Must produce: ~half a page, own words, grouped by theme, no verbatim copying.</a:t>
+            </a:r>
+          </a:p>
+          <a:p>
+            <a:r>
+              <a:t>Timing: ~20 min then discuss. Where they get stuck: they PASTE spec tables verbatim — circulate and</a:t>
+            </a:r>
+          </a:p>
+          <a:p>
+            <a:r>
+              <a:t>make them re-state in plain language; also watch for irrelevant detail creeping in.</a:t>
+            </a:r>
+          </a:p>
+          <a:p>
+            <a:r>
+              <a:t>Share-back prompt: "Which limitation in your current state most obviously sets up a gap?" (bridges to</a:t>
+            </a:r>
+          </a:p>
+          <a:p>
+            <a:r>
+              <a:t>Section 3).</a:t>
+            </a:r>
+          </a:p>
+          <a:p>
+            <a:r>
+              <a:t>No-leakage note: Ledgerline is PRACTICE; AT1 assesses the same synthesis skill on the LMS —</a:t>
+            </a:r>
+          </a:p>
+          <a:p>
+            <a:r>
+              <a:t>comparable, not identical. Keep them on the scenario source docs.</a:t>
+            </a:r>
+          </a:p>
+        </p:txBody>
+      </p:sp>
+      <p:sp>
+        <p:nvSpPr>
+          <p:cNvPr id="4" name="Slide Number Placeholder 3"/>
+          <p:cNvSpPr>
+            <a:spLocks noGrp="1"/>
+          </p:cNvSpPr>
+          <p:nvPr>
+            <p:ph type="sldNum" idx="5" sz="quarter"/>
+          </p:nvPr>
+        </p:nvSpPr>
+        <p:spPr/>
+      </p:sp>
+    </p:spTree>
+  </p:cSld>
+  <p:clrMapOvr>
+    <a:masterClrMapping/>
+  </p:clrMapOvr>
+</p:notes>
+</file>
+
+<file path=ppt/notesSlides/notesSlide12.xml><?xml version="1.0" encoding="utf-8"?>
+<p:notes xmlns:a="http://schemas.openxmlformats.org/drawingml/2006/main" xmlns:p="http://schemas.openxmlformats.org/presentationml/2006/main" xmlns:r="http://schemas.openxmlformats.org/officeDocument/2006/relationships">
+  <p:cSld>
+    <p:spTree>
+      <p:nvGrpSpPr>
+        <p:cNvPr id="1" name=""/>
+        <p:cNvGrpSpPr/>
+        <p:nvPr/>
+      </p:nvGrpSpPr>
+      <p:grpSpPr>
+        <a:xfrm>
+          <a:off x="0" y="0"/>
+          <a:ext cx="0" cy="0"/>
+          <a:chOff x="0" y="0"/>
+          <a:chExt cx="0" cy="0"/>
+        </a:xfrm>
+      </p:grpSpPr>
+      <p:sp>
+        <p:nvSpPr>
+          <p:cNvPr id="2" name="Slide Image Placeholder 1"/>
+          <p:cNvSpPr>
+            <a:spLocks noGrp="1"/>
+          </p:cNvSpPr>
+          <p:nvPr>
+            <p:ph type="sldImg" idx="2"/>
+          </p:nvPr>
+        </p:nvSpPr>
+        <p:spPr/>
+      </p:sp>
+      <p:sp>
+        <p:nvSpPr>
+          <p:cNvPr id="3" name="Notes Placeholder 2"/>
+          <p:cNvSpPr>
+            <a:spLocks noGrp="1"/>
+          </p:cNvSpPr>
+          <p:nvPr>
+            <p:ph type="body" idx="3" sz="quarter"/>
+          </p:nvPr>
+        </p:nvSpPr>
+        <p:spPr/>
+        <p:txBody>
+          <a:bodyPr/>
+          <a:lstStyle/>
+          <a:p>
+            <a:r>
+              <a:t>Open Section 3 — teach gap analysis as the BRIDGE that makes the problem concrete and hands the next</a:t>
+            </a:r>
+          </a:p>
+          <a:p>
+            <a:r>
+              <a:t>stage its worklist.</a:t>
+            </a:r>
+          </a:p>
+          <a:p>
+            <a:r>
+              <a:t>• First bullet: it bridges where we want to be (strategy + requirements) and where we are (your</a:t>
+            </a:r>
+          </a:p>
+          <a:p>
+            <a:r>
+              <a:t>  current state) — it literally joins §3 to §4.</a:t>
+            </a:r>
+          </a:p>
+          <a:p>
+            <a:r>
+              <a:t>• Second/third bullets: it makes the problem CONCRETE and MEASURABLE, and it hands the next stage a</a:t>
+            </a:r>
+          </a:p>
+          <a:p>
+            <a:r>
+              <a:t>  list of changes to evaluate (the seed of Topic 3's options).</a:t>
+            </a:r>
+          </a:p>
+          <a:p>
+            <a:r>
+              <a:t>• The green line: "No gap → no case." If you can't show a gap, there's no justified change — say it.</a:t>
+            </a:r>
+          </a:p>
+          <a:p>
+            <a:r>
+              <a:t>Misconception to pre-empt: "the gap analysis is where I propose the solution." No — the "proposed</a:t>
+            </a:r>
+          </a:p>
+          <a:p>
+            <a:r>
+              <a:t>change" is a CANDIDATE to evaluate later, not a decision; gap analysis proves the problem, Topic 3</a:t>
+            </a:r>
+          </a:p>
+          <a:p>
+            <a:r>
+              <a:t>weighs the fix.</a:t>
+            </a:r>
+          </a:p>
+          <a:p>
+            <a:r>
+              <a:t>Question to pose: "Where do the 'desired' and 'current' columns each come from?" (desired ← strategy</a:t>
+            </a:r>
+          </a:p>
+          <a:p>
+            <a:r>
+              <a:t>+ requirements; current ← your §4 synthesis — it's traceable both ways).</a:t>
+            </a:r>
+          </a:p>
+          <a:p>
+            <a:r>
+              <a:t>UoC/AT1 tie: PC 1.3 / PE 3 → AT1 §5 Gap Analysis (criterion A3); it's the hinge into the options work.</a:t>
+            </a:r>
+          </a:p>
+        </p:txBody>
+      </p:sp>
+      <p:sp>
+        <p:nvSpPr>
+          <p:cNvPr id="4" name="Slide Number Placeholder 3"/>
+          <p:cNvSpPr>
+            <a:spLocks noGrp="1"/>
+          </p:cNvSpPr>
+          <p:nvPr>
+            <p:ph type="sldNum" idx="5" sz="quarter"/>
+          </p:nvPr>
+        </p:nvSpPr>
+        <p:spPr/>
+      </p:sp>
+    </p:spTree>
+  </p:cSld>
+  <p:clrMapOvr>
+    <a:masterClrMapping/>
+  </p:clrMapOvr>
+</p:notes>
+</file>
+
+<file path=ppt/notesSlides/notesSlide13.xml><?xml version="1.0" encoding="utf-8"?>
+<p:notes xmlns:a="http://schemas.openxmlformats.org/drawingml/2006/main" xmlns:p="http://schemas.openxmlformats.org/presentationml/2006/main" xmlns:r="http://schemas.openxmlformats.org/officeDocument/2006/relationships">
+  <p:cSld>
+    <p:spTree>
+      <p:nvGrpSpPr>
+        <p:cNvPr id="1" name=""/>
+        <p:cNvGrpSpPr/>
+        <p:nvPr/>
+      </p:nvGrpSpPr>
+      <p:grpSpPr>
+        <a:xfrm>
+          <a:off x="0" y="0"/>
+          <a:ext cx="0" cy="0"/>
+          <a:chOff x="0" y="0"/>
+          <a:chExt cx="0" cy="0"/>
+        </a:xfrm>
+      </p:grpSpPr>
+      <p:sp>
+        <p:nvSpPr>
+          <p:cNvPr id="2" name="Slide Image Placeholder 1"/>
+          <p:cNvSpPr>
+            <a:spLocks noGrp="1"/>
+          </p:cNvSpPr>
+          <p:nvPr>
+            <p:ph type="sldImg" idx="2"/>
+          </p:nvPr>
+        </p:nvSpPr>
+        <p:spPr/>
+      </p:sp>
+      <p:sp>
+        <p:nvSpPr>
+          <p:cNvPr id="3" name="Notes Placeholder 2"/>
+          <p:cNvSpPr>
+            <a:spLocks noGrp="1"/>
+          </p:cNvSpPr>
+          <p:nvPr>
+            <p:ph type="body" idx="3" sz="quarter"/>
+          </p:nvPr>
+        </p:nvSpPr>
+        <p:spPr/>
+        <p:txBody>
+          <a:bodyPr/>
+          <a:lstStyle/>
+          <a:p>
+            <a:r>
+              <a:t>Facilitation — the Section 3 practice; students build §5 of the practice business case (Ledgerline)</a:t>
+            </a:r>
+          </a:p>
+          <a:p>
+            <a:r>
+              <a:t>as a structured gap table, mirroring AT1 §5.</a:t>
+            </a:r>
+          </a:p>
+          <a:p>
+            <a:r>
+              <a:t>Tell students: "In your working copy of the Business Case, add the Gap Analysis for the Accounting</a:t>
+            </a:r>
+          </a:p>
+          <a:p>
+            <a:r>
+              <a:t>System (Ledgerline) — a table of at least 3 rows, every column filled and traceable."</a:t>
+            </a:r>
+          </a:p>
+          <a:p>
+            <a:r>
+              <a:t>Steps (put on the board):</a:t>
+            </a:r>
+          </a:p>
+          <a:p>
+            <a:r>
+              <a:t>1. Draw objectives from your Strategic Alignment work + the migration requirements, e.g.: reduce</a:t>
+            </a:r>
+          </a:p>
+          <a:p>
+            <a:r>
+              <a:t>   in-house infrastructure dependency (ageing server); business-hours availability &gt;=99.5% (RPO &lt;=1h /</a:t>
+            </a:r>
+          </a:p>
+          <a:p>
+            <a:r>
+              <a:t>   RTO &lt;=1 business day); keep financial data onshore + 7-year retention; size for month-end / EOFY</a:t>
+            </a:r>
+          </a:p>
+          <a:p>
+            <a:r>
+              <a:t>   peaks without year-round over-provisioning.</a:t>
+            </a:r>
+          </a:p>
+          <a:p>
+            <a:r>
+              <a:t>2. Fill every column: objective → current → desired → gap → opportunity → proposed change.</a:t>
+            </a:r>
+          </a:p>
+          <a:p>
+            <a:r>
+              <a:t>3. Check each row traces BACK to a real objective (from §3) and your current-state facts (from §4).</a:t>
+            </a:r>
+          </a:p>
+          <a:p>
+            <a:r>
+              <a:t>Must produce: a &gt;=3-row gap table, all six columns filled, each row traceable both ways.</a:t>
+            </a:r>
+          </a:p>
+          <a:p>
+            <a:r>
+              <a:t>Timing: ~25 min then discuss. Where they get stuck: they jump to "move to AWS" in every "proposed</a:t>
+            </a:r>
+          </a:p>
+          <a:p>
+            <a:r>
+              <a:t>change" cell — remind them proposed change is a CANDIDATE seed, not a chosen solution; and they leave</a:t>
+            </a:r>
+          </a:p>
+          <a:p>
+            <a:r>
+              <a:t>"opportunity" blank — it's the bridge from gap to proposed change.</a:t>
+            </a:r>
+          </a:p>
+          <a:p>
+            <a:r>
+              <a:t>Share-back prompt: take one row and trace it end-to-end — objective from the plan, current from §4.</a:t>
+            </a:r>
+          </a:p>
+          <a:p>
+            <a:r>
+              <a:t>No-leakage note: Ledgerline is PRACTICE; AT1 assesses the gap-analysis skill on the LMS — comparable,</a:t>
+            </a:r>
+          </a:p>
+          <a:p>
+            <a:r>
+              <a:t>not identical.</a:t>
+            </a:r>
+          </a:p>
+        </p:txBody>
+      </p:sp>
+      <p:sp>
+        <p:nvSpPr>
+          <p:cNvPr id="4" name="Slide Number Placeholder 3"/>
+          <p:cNvSpPr>
+            <a:spLocks noGrp="1"/>
+          </p:cNvSpPr>
+          <p:nvPr>
+            <p:ph type="sldNum" idx="5" sz="quarter"/>
+          </p:nvPr>
+        </p:nvSpPr>
+        <p:spPr/>
+      </p:sp>
+    </p:spTree>
+  </p:cSld>
+  <p:clrMapOvr>
+    <a:masterClrMapping/>
+  </p:clrMapOvr>
+</p:notes>
+</file>
+
+<file path=ppt/notesSlides/notesSlide2.xml><?xml version="1.0" encoding="utf-8"?>
+<p:notes xmlns:a="http://schemas.openxmlformats.org/drawingml/2006/main" xmlns:p="http://schemas.openxmlformats.org/presentationml/2006/main" xmlns:r="http://schemas.openxmlformats.org/officeDocument/2006/relationships">
+  <p:cSld>
+    <p:spTree>
+      <p:nvGrpSpPr>
+        <p:cNvPr id="1" name=""/>
+        <p:cNvGrpSpPr/>
+        <p:nvPr/>
+      </p:nvGrpSpPr>
+      <p:grpSpPr>
+        <a:xfrm>
+          <a:off x="0" y="0"/>
+          <a:ext cx="0" cy="0"/>
+          <a:chOff x="0" y="0"/>
+          <a:chExt cx="0" cy="0"/>
+        </a:xfrm>
+      </p:grpSpPr>
+      <p:sp>
+        <p:nvSpPr>
+          <p:cNvPr id="2" name="Slide Image Placeholder 1"/>
+          <p:cNvSpPr>
+            <a:spLocks noGrp="1"/>
+          </p:cNvSpPr>
+          <p:nvPr>
+            <p:ph type="sldImg" idx="2"/>
+          </p:nvPr>
+        </p:nvSpPr>
+        <p:spPr/>
+      </p:sp>
+      <p:sp>
+        <p:nvSpPr>
+          <p:cNvPr id="3" name="Notes Placeholder 2"/>
+          <p:cNvSpPr>
+            <a:spLocks noGrp="1"/>
+          </p:cNvSpPr>
+          <p:nvPr>
+            <p:ph type="body" idx="3" sz="quarter"/>
+          </p:nvPr>
+        </p:nvSpPr>
+        <p:spPr/>
+        <p:txBody>
+          <a:bodyPr/>
+          <a:lstStyle/>
+          <a:p>
+            <a:r>
+              <a:t>The anchor framing for the Topic — a case for change is an EVIDENCE chain, not a hunch. Teach it</a:t>
+            </a:r>
+          </a:p>
+          <a:p>
+            <a:r>
+              <a:t>deliberately; the three-question order is the skeleton of everything today.</a:t>
+            </a:r>
+          </a:p>
+          <a:p>
+            <a:r>
+              <a:t>• Walk the three questions in order: where does the org want to go (strategy) → where is it now</a:t>
+            </a:r>
+          </a:p>
+          <a:p>
+            <a:r>
+              <a:t>  (current state) → what's missing to get there (gaps). Each answer feeds the next.</a:t>
+            </a:r>
+          </a:p>
+          <a:p>
+            <a:r>
+              <a:t>• Stress the last two bullets: they are NOT choosing a solution yet — they're proving the problem</a:t>
+            </a:r>
+          </a:p>
+          <a:p>
+            <a:r>
+              <a:t>  is real and worth solving. "Diagnose before you prescribe" (the magenta line) is the Topic's motto.</a:t>
+            </a:r>
+          </a:p>
+          <a:p>
+            <a:r>
+              <a:t>Misconception to pre-empt: students treat "the case for change" as arguing FOR cloud. It isn't — it</a:t>
+            </a:r>
+          </a:p>
+          <a:p>
+            <a:r>
+              <a:t>argues the problem exists; the solution could even be "renew on-prem". Keep it solution-neutral.</a:t>
+            </a:r>
+          </a:p>
+          <a:p>
+            <a:r>
+              <a:t>Question to pose: "If a doctor prescribed before diagnosing, what would go wrong — and how is a rushed</a:t>
+            </a:r>
+          </a:p>
+          <a:p>
+            <a:r>
+              <a:t>cloud recommendation the same mistake?"</a:t>
+            </a:r>
+          </a:p>
+          <a:p>
+            <a:r>
+              <a:t>UoC/AT1 tie: PE 1–3 in sequence; this three-part spine maps one-to-one onto AT1 §3 / §4 / §5.</a:t>
+            </a:r>
+          </a:p>
+        </p:txBody>
+      </p:sp>
+      <p:sp>
+        <p:nvSpPr>
+          <p:cNvPr id="4" name="Slide Number Placeholder 3"/>
+          <p:cNvSpPr>
+            <a:spLocks noGrp="1"/>
+          </p:cNvSpPr>
+          <p:nvPr>
+            <p:ph type="sldNum" idx="5" sz="quarter"/>
+          </p:nvPr>
+        </p:nvSpPr>
+        <p:spPr/>
+      </p:sp>
+    </p:spTree>
+  </p:cSld>
+  <p:clrMapOvr>
+    <a:masterClrMapping/>
+  </p:clrMapOvr>
+</p:notes>
+</file>
+
+<file path=ppt/notesSlides/notesSlide3.xml><?xml version="1.0" encoding="utf-8"?>
+<p:notes xmlns:a="http://schemas.openxmlformats.org/drawingml/2006/main" xmlns:p="http://schemas.openxmlformats.org/presentationml/2006/main" xmlns:r="http://schemas.openxmlformats.org/officeDocument/2006/relationships">
+  <p:cSld>
+    <p:spTree>
+      <p:nvGrpSpPr>
+        <p:cNvPr id="1" name=""/>
+        <p:cNvGrpSpPr/>
+        <p:nvPr/>
+      </p:nvGrpSpPr>
+      <p:grpSpPr>
+        <a:xfrm>
+          <a:off x="0" y="0"/>
+          <a:ext cx="0" cy="0"/>
+          <a:chOff x="0" y="0"/>
+          <a:chExt cx="0" cy="0"/>
+        </a:xfrm>
+      </p:grpSpPr>
+      <p:sp>
+        <p:nvSpPr>
+          <p:cNvPr id="2" name="Slide Image Placeholder 1"/>
+          <p:cNvSpPr>
+            <a:spLocks noGrp="1"/>
+          </p:cNvSpPr>
+          <p:nvPr>
+            <p:ph type="sldImg" idx="2"/>
+          </p:nvPr>
+        </p:nvSpPr>
+        <p:spPr/>
+      </p:sp>
+      <p:sp>
+        <p:nvSpPr>
+          <p:cNvPr id="3" name="Notes Placeholder 2"/>
+          <p:cNvSpPr>
+            <a:spLocks noGrp="1"/>
+          </p:cNvSpPr>
+          <p:nvPr>
+            <p:ph type="body" idx="3" sz="quarter"/>
+          </p:nvPr>
+        </p:nvSpPr>
+        <p:spPr/>
+        <p:txBody>
+          <a:bodyPr/>
+          <a:lstStyle/>
+          <a:p>
+            <a:r>
+              <a:t>Open Section 1. Teach WHY the business case leads with strategy — it's what unlocks funding.</a:t>
+            </a:r>
+          </a:p>
+          <a:p>
+            <a:r>
+              <a:t>• First two bullets: a board funds change that moves the organisation toward ITS OWN stated goals;</a:t>
+            </a:r>
+          </a:p>
+          <a:p>
+            <a:r>
+              <a:t>  so you lead by showing the initiative serves the strategy, not technology for its own sake.</a:t>
+            </a:r>
+          </a:p>
+          <a:p>
+            <a:r>
+              <a:t>• Third bullet: define strategic alignment plainly — "here's what they said they want; here's how</a:t>
+            </a:r>
+          </a:p>
+          <a:p>
+            <a:r>
+              <a:t>  this delivers it." It's an argument, not a description.</a:t>
+            </a:r>
+          </a:p>
+          <a:p>
+            <a:r>
+              <a:t>• Fourth bullet (bolded): it's the "why this, why now" that earns everything downstream. If you can't</a:t>
+            </a:r>
+          </a:p>
+          <a:p>
+            <a:r>
+              <a:t>  tie the initiative to a stated goal, the case is already weak.</a:t>
+            </a:r>
+          </a:p>
+          <a:p>
+            <a:r>
+              <a:t>Misconception to pre-empt: "strategic alignment = describe the company." No — it's a targeted argument</a:t>
+            </a:r>
+          </a:p>
+          <a:p>
+            <a:r>
+              <a:t>connecting THIS initiative to a specific organisational objective, with a citation.</a:t>
+            </a:r>
+          </a:p>
+          <a:p>
+            <a:r>
+              <a:t>Question to pose: "YAT's board has limited money — why would 'the servers are old' persuade them less</a:t>
+            </a:r>
+          </a:p>
+          <a:p>
+            <a:r>
+              <a:t>than 'this serves your national-growth goal'?" (funders back strategy, not maintenance).</a:t>
+            </a:r>
+          </a:p>
+          <a:p>
+            <a:r>
+              <a:t>UoC/AT1 tie: PC 1.1 / PE 1 → AT1 §3 Strategic Alignment Analysis (criterion A1).</a:t>
+            </a:r>
+          </a:p>
+        </p:txBody>
+      </p:sp>
+      <p:sp>
+        <p:nvSpPr>
+          <p:cNvPr id="4" name="Slide Number Placeholder 3"/>
+          <p:cNvSpPr>
+            <a:spLocks noGrp="1"/>
+          </p:cNvSpPr>
+          <p:nvPr>
+            <p:ph type="sldNum" idx="5" sz="quarter"/>
+          </p:nvPr>
+        </p:nvSpPr>
+        <p:spPr/>
+      </p:sp>
+    </p:spTree>
+  </p:cSld>
+  <p:clrMapOvr>
+    <a:masterClrMapping/>
+  </p:clrMapOvr>
+</p:notes>
+</file>
+
+<file path=ppt/notesSlides/notesSlide4.xml><?xml version="1.0" encoding="utf-8"?>
+<p:notes xmlns:a="http://schemas.openxmlformats.org/drawingml/2006/main" xmlns:p="http://schemas.openxmlformats.org/presentationml/2006/main" xmlns:r="http://schemas.openxmlformats.org/officeDocument/2006/relationships">
+  <p:cSld>
+    <p:spTree>
+      <p:nvGrpSpPr>
+        <p:cNvPr id="1" name=""/>
+        <p:cNvGrpSpPr/>
+        <p:nvPr/>
+      </p:nvGrpSpPr>
+      <p:grpSpPr>
+        <a:xfrm>
+          <a:off x="0" y="0"/>
+          <a:ext cx="0" cy="0"/>
+          <a:chOff x="0" y="0"/>
+          <a:chExt cx="0" cy="0"/>
+        </a:xfrm>
+      </p:grpSpPr>
+      <p:sp>
+        <p:nvSpPr>
+          <p:cNvPr id="2" name="Slide Image Placeholder 1"/>
+          <p:cNvSpPr>
+            <a:spLocks noGrp="1"/>
+          </p:cNvSpPr>
+          <p:nvPr>
+            <p:ph type="sldImg" idx="2"/>
+          </p:nvPr>
+        </p:nvSpPr>
+        <p:spPr/>
+      </p:sp>
+      <p:sp>
+        <p:nvSpPr>
+          <p:cNvPr id="3" name="Notes Placeholder 2"/>
+          <p:cNvSpPr>
+            <a:spLocks noGrp="1"/>
+          </p:cNvSpPr>
+          <p:nvPr>
+            <p:ph type="body" idx="3" sz="quarter"/>
+          </p:nvPr>
+        </p:nvSpPr>
+        <p:spPr/>
+        <p:txBody>
+          <a:bodyPr/>
+          <a:lstStyle/>
+          <a:p>
+            <a:r>
+              <a:t>The how-to slide for Section 1 — teach students to READ a strategic plan structurally instead of</a:t>
+            </a:r>
+          </a:p>
+          <a:p>
+            <a:r>
+              <a:t>skimming it. The three layers are the examinable technique.</a:t>
+            </a:r>
+          </a:p>
+          <a:p>
+            <a:r>
+              <a:t>• Walk the layers top-down: business objectives (where the whole org is going, e.g. grow students</a:t>
+            </a:r>
+          </a:p>
+          <a:p>
+            <a:r>
+              <a:t>  15%/yr) → ICT goals (how ICT supports that, e.g. reduce in-house dependency, 99.9% for critical</a:t>
+            </a:r>
+          </a:p>
+          <a:p>
+            <a:r>
+              <a:t>  systems) → initiatives (the planned actions, e.g. move suitable systems to cloud).</a:t>
+            </a:r>
+          </a:p>
+          <a:p>
+            <a:r>
+              <a:t>• The payoff (magenta line): trace YOUR initiative UP these layers to a real business objective, and</a:t>
+            </a:r>
+          </a:p>
+          <a:p>
+            <a:r>
+              <a:t>  pull only what's MATERIAL — don't recite the whole plan.</a:t>
+            </a:r>
+          </a:p>
+          <a:p>
+            <a:r>
+              <a:t>Misconception to pre-empt: students copy every objective in the plan. No — most won't be relevant;</a:t>
+            </a:r>
+          </a:p>
+          <a:p>
+            <a:r>
+              <a:t>selecting the material few and tracing them up is the analytical skill being marked.</a:t>
+            </a:r>
+          </a:p>
+          <a:p>
+            <a:r>
+              <a:t>Question to pose: "Migrating Ledgerline — which ICT goal does it serve, and which business objective</a:t>
+            </a:r>
+          </a:p>
+          <a:p>
+            <a:r>
+              <a:t>sits above that goal?" (traces the chain live).</a:t>
+            </a:r>
+          </a:p>
+          <a:p>
+            <a:r>
+              <a:t>UoC/AT1 tie: PC 1.1 / PE 1 → AT1 §3; the "trace up, material only" habit is exactly what A1 rewards.</a:t>
+            </a:r>
+          </a:p>
+        </p:txBody>
+      </p:sp>
+      <p:sp>
+        <p:nvSpPr>
+          <p:cNvPr id="4" name="Slide Number Placeholder 3"/>
+          <p:cNvSpPr>
+            <a:spLocks noGrp="1"/>
+          </p:cNvSpPr>
+          <p:nvPr>
+            <p:ph type="sldNum" idx="5" sz="quarter"/>
+          </p:nvPr>
+        </p:nvSpPr>
+        <p:spPr/>
+      </p:sp>
+    </p:spTree>
+  </p:cSld>
+  <p:clrMapOvr>
+    <a:masterClrMapping/>
+  </p:clrMapOvr>
+</p:notes>
+</file>
+
+<file path=ppt/notesSlides/notesSlide5.xml><?xml version="1.0" encoding="utf-8"?>
+<p:notes xmlns:a="http://schemas.openxmlformats.org/drawingml/2006/main" xmlns:p="http://schemas.openxmlformats.org/presentationml/2006/main" xmlns:r="http://schemas.openxmlformats.org/officeDocument/2006/relationships">
+  <p:cSld>
+    <p:spTree>
+      <p:nvGrpSpPr>
+        <p:cNvPr id="1" name=""/>
+        <p:cNvGrpSpPr/>
+        <p:nvPr/>
+      </p:nvGrpSpPr>
+      <p:grpSpPr>
+        <a:xfrm>
+          <a:off x="0" y="0"/>
+          <a:ext cx="0" cy="0"/>
+          <a:chOff x="0" y="0"/>
+          <a:chExt cx="0" cy="0"/>
+        </a:xfrm>
+      </p:grpSpPr>
+      <p:sp>
+        <p:nvSpPr>
+          <p:cNvPr id="2" name="Slide Image Placeholder 1"/>
+          <p:cNvSpPr>
+            <a:spLocks noGrp="1"/>
+          </p:cNvSpPr>
+          <p:nvPr>
+            <p:ph type="sldImg" idx="2"/>
+          </p:nvPr>
+        </p:nvSpPr>
+        <p:spPr/>
+      </p:sp>
+      <p:sp>
+        <p:nvSpPr>
+          <p:cNvPr id="3" name="Notes Placeholder 2"/>
+          <p:cNvSpPr>
+            <a:spLocks noGrp="1"/>
+          </p:cNvSpPr>
+          <p:nvPr>
+            <p:ph type="body" idx="3" sz="quarter"/>
+          </p:nvPr>
+        </p:nvSpPr>
+        <p:spPr/>
+        <p:txBody>
+          <a:bodyPr/>
+          <a:lstStyle/>
+          <a:p>
+            <a:r>
+              <a:t>Second half of Section 1 — a strategic argument needs the EXTERNAL industry context, not just the</a:t>
+            </a:r>
+          </a:p>
+          <a:p>
+            <a:r>
+              <a:t>client's internal plan.</a:t>
+            </a:r>
+          </a:p>
+          <a:p>
+            <a:r>
+              <a:t>• First bullet: a plan doesn't exist in a vacuum; compare it against where the industry is heading.</a:t>
+            </a:r>
+          </a:p>
+          <a:p>
+            <a:r>
+              <a:t>• Second bullet: name the trends that matter here — cloud adoption, managed services, OPEX over CAPEX,</a:t>
+            </a:r>
+          </a:p>
+          <a:p>
+            <a:r>
+              <a:t>  resilience. These are the yardsticks.</a:t>
+            </a:r>
+          </a:p>
+          <a:p>
+            <a:r>
+              <a:t>• Third/fourth bullets: name BOTH directions — alignment (plan matches industry direction →</a:t>
+            </a:r>
+          </a:p>
+          <a:p>
+            <a:r>
+              <a:t>  strengthens the case) and divergence (plan lags or differs → a risk, or an opportunity to flag).</a:t>
+            </a:r>
+          </a:p>
+          <a:p>
+            <a:r>
+              <a:t>Misconception to pre-empt: "industry context = cheerlead for cloud." No — a balanced analysis names</a:t>
+            </a:r>
+          </a:p>
+          <a:p>
+            <a:r>
+              <a:t>where the client is behind AND where a trend might not fit them; honesty is the mark of analysis.</a:t>
+            </a:r>
+          </a:p>
+          <a:p>
+            <a:r>
+              <a:t>Question to pose: "The sector is moving to managed cloud services — where does that ALIGN with YAT's</a:t>
+            </a:r>
+          </a:p>
+          <a:p>
+            <a:r>
+              <a:t>plan, and is there anywhere it might DIVERGE for a small RTO?"</a:t>
+            </a:r>
+          </a:p>
+          <a:p>
+            <a:r>
+              <a:t>UoC/AT1 tie: KE 4 (current/emerging trends and directions) → AT1 §3; the outside view is what lifts</a:t>
+            </a:r>
+          </a:p>
+          <a:p>
+            <a:r>
+              <a:t>A1 from description to analysis.</a:t>
+            </a:r>
+          </a:p>
+        </p:txBody>
+      </p:sp>
+      <p:sp>
+        <p:nvSpPr>
+          <p:cNvPr id="4" name="Slide Number Placeholder 3"/>
+          <p:cNvSpPr>
+            <a:spLocks noGrp="1"/>
+          </p:cNvSpPr>
+          <p:nvPr>
+            <p:ph type="sldNum" idx="5" sz="quarter"/>
+          </p:nvPr>
+        </p:nvSpPr>
+        <p:spPr/>
+      </p:sp>
+    </p:spTree>
+  </p:cSld>
+  <p:clrMapOvr>
+    <a:masterClrMapping/>
+  </p:clrMapOvr>
+</p:notes>
+</file>
+
+<file path=ppt/notesSlides/notesSlide6.xml><?xml version="1.0" encoding="utf-8"?>
+<p:notes xmlns:a="http://schemas.openxmlformats.org/drawingml/2006/main" xmlns:p="http://schemas.openxmlformats.org/presentationml/2006/main" xmlns:r="http://schemas.openxmlformats.org/officeDocument/2006/relationships">
+  <p:cSld>
+    <p:spTree>
+      <p:nvGrpSpPr>
+        <p:cNvPr id="1" name=""/>
+        <p:cNvGrpSpPr/>
+        <p:nvPr/>
+      </p:nvGrpSpPr>
+      <p:grpSpPr>
+        <a:xfrm>
+          <a:off x="0" y="0"/>
+          <a:ext cx="0" cy="0"/>
+          <a:chOff x="0" y="0"/>
+          <a:chExt cx="0" cy="0"/>
+        </a:xfrm>
+      </p:grpSpPr>
+      <p:sp>
+        <p:nvSpPr>
+          <p:cNvPr id="2" name="Slide Image Placeholder 1"/>
+          <p:cNvSpPr>
+            <a:spLocks noGrp="1"/>
+          </p:cNvSpPr>
+          <p:nvPr>
+            <p:ph type="sldImg" idx="2"/>
+          </p:nvPr>
+        </p:nvSpPr>
+        <p:spPr/>
+      </p:sp>
+      <p:sp>
+        <p:nvSpPr>
+          <p:cNvPr id="3" name="Notes Placeholder 2"/>
+          <p:cNvSpPr>
+            <a:spLocks noGrp="1"/>
+          </p:cNvSpPr>
+          <p:nvPr>
+            <p:ph type="body" idx="3" sz="quarter"/>
+          </p:nvPr>
+        </p:nvSpPr>
+        <p:spPr/>
+        <p:txBody>
+          <a:bodyPr/>
+          <a:lstStyle/>
+          <a:p>
+            <a:r>
+              <a:t>The quality checklist for Section 1 — read it as the marker's-eye view of a strong §3, right before</a:t>
+            </a:r>
+          </a:p>
+          <a:p>
+            <a:r>
+              <a:t>they attempt it. Keep it short; it's a rubric, not new content.</a:t>
+            </a:r>
+          </a:p>
+          <a:p>
+            <a:r>
+              <a:t>• Every claim CITED to the plan (e.g. "ICT Strategic Plan — ICT Goals") — no unsourced assertions.</a:t>
+            </a:r>
+          </a:p>
+          <a:p>
+            <a:r>
+              <a:t>• MATERIAL items only — not the whole plan recited.</a:t>
+            </a:r>
+          </a:p>
+          <a:p>
+            <a:r>
+              <a:t>• TRACES the initiative up to a real organisational goal (the three-layer move).</a:t>
+            </a:r>
+          </a:p>
+          <a:p>
+            <a:r>
+              <a:t>• ALIGNMENT AND DIVERGENCE both named (magenta line) — balanced, not cheerleading.</a:t>
+            </a:r>
+          </a:p>
+          <a:p>
+            <a:r>
+              <a:t>Misconception to pre-empt: "more is better." No — a padded §3 that recites the plan scores worse than</a:t>
+            </a:r>
+          </a:p>
+          <a:p>
+            <a:r>
+              <a:t>a tight one that cites four material objectives and traces them.</a:t>
+            </a:r>
+          </a:p>
+          <a:p>
+            <a:r>
+              <a:t>Question to pose: "If I marked your §3, what's the single fastest way to lose marks?" (uncited claims /</a:t>
+            </a:r>
+          </a:p>
+          <a:p>
+            <a:r>
+              <a:t>reciting everything / no divergence named).</a:t>
+            </a:r>
+          </a:p>
+          <a:p>
+            <a:r>
+              <a:t>UoC/AT1 tie: this is the A1 acceptance standard for AT1 §3 — hand them the bar before the activity.</a:t>
+            </a:r>
+          </a:p>
+        </p:txBody>
+      </p:sp>
+      <p:sp>
+        <p:nvSpPr>
+          <p:cNvPr id="4" name="Slide Number Placeholder 3"/>
+          <p:cNvSpPr>
+            <a:spLocks noGrp="1"/>
+          </p:cNvSpPr>
+          <p:nvPr>
+            <p:ph type="sldNum" idx="5" sz="quarter"/>
+          </p:nvPr>
+        </p:nvSpPr>
+        <p:spPr/>
+      </p:sp>
+    </p:spTree>
+  </p:cSld>
+  <p:clrMapOvr>
+    <a:masterClrMapping/>
+  </p:clrMapOvr>
+</p:notes>
+</file>
+
+<file path=ppt/notesSlides/notesSlide7.xml><?xml version="1.0" encoding="utf-8"?>
+<p:notes xmlns:a="http://schemas.openxmlformats.org/drawingml/2006/main" xmlns:p="http://schemas.openxmlformats.org/presentationml/2006/main" xmlns:r="http://schemas.openxmlformats.org/officeDocument/2006/relationships">
+  <p:cSld>
+    <p:spTree>
+      <p:nvGrpSpPr>
+        <p:cNvPr id="1" name=""/>
+        <p:cNvGrpSpPr/>
+        <p:nvPr/>
+      </p:nvGrpSpPr>
+      <p:grpSpPr>
+        <a:xfrm>
+          <a:off x="0" y="0"/>
+          <a:ext cx="0" cy="0"/>
+          <a:chOff x="0" y="0"/>
+          <a:chExt cx="0" cy="0"/>
+        </a:xfrm>
+      </p:grpSpPr>
+      <p:sp>
+        <p:nvSpPr>
+          <p:cNvPr id="2" name="Slide Image Placeholder 1"/>
+          <p:cNvSpPr>
+            <a:spLocks noGrp="1"/>
+          </p:cNvSpPr>
+          <p:nvPr>
+            <p:ph type="sldImg" idx="2"/>
+          </p:nvPr>
+        </p:nvSpPr>
+        <p:spPr/>
+      </p:sp>
+      <p:sp>
+        <p:nvSpPr>
+          <p:cNvPr id="3" name="Notes Placeholder 2"/>
+          <p:cNvSpPr>
+            <a:spLocks noGrp="1"/>
+          </p:cNvSpPr>
+          <p:nvPr>
+            <p:ph type="body" idx="3" sz="quarter"/>
+          </p:nvPr>
+        </p:nvSpPr>
+        <p:spPr/>
+        <p:txBody>
+          <a:bodyPr/>
+          <a:lstStyle/>
+          <a:p>
+            <a:r>
+              <a:t>Facilitation — the Section 1 practice; students draft §3 of the PRACTICE business case (Ledgerline).</a:t>
+            </a:r>
+          </a:p>
+          <a:p>
+            <a:r>
+              <a:t>This mirrors AT1 §3 against a different system.</a:t>
+            </a:r>
+          </a:p>
+          <a:p>
+            <a:r>
+              <a:t>Tell students: "In your working copy of the Business Case, write the Strategic Alignment section for</a:t>
+            </a:r>
+          </a:p>
+          <a:p>
+            <a:r>
+              <a:t>moving YAT's Accounting System (Ledgerline) to the cloud. Argue it — don't just describe."</a:t>
+            </a:r>
+          </a:p>
+          <a:p>
+            <a:r>
+              <a:t>Steps (put on the board):</a:t>
+            </a:r>
+          </a:p>
+          <a:p>
+            <a:r>
+              <a:t>1. Read YAT's ICT Strategic Plan on the scenario intranet.</a:t>
+            </a:r>
+          </a:p>
+          <a:p>
+            <a:r>
+              <a:t>2. Which ICT goals/objectives does this migration serve? Trace up to a business objective — CITE them.</a:t>
+            </a:r>
+          </a:p>
+          <a:p>
+            <a:r>
+              <a:t>3. Add one or two points of industry context — where's the sector heading?</a:t>
+            </a:r>
+          </a:p>
+          <a:p>
+            <a:r>
+              <a:t>4. Note both alignment and divergence honestly.</a:t>
+            </a:r>
+          </a:p>
+          <a:p>
+            <a:r>
+              <a:t>Must produce: ~half a page — a cited strategic-alignment argument, traced up the three layers, with</a:t>
+            </a:r>
+          </a:p>
+          <a:p>
+            <a:r>
+              <a:t>alignment AND divergence named.</a:t>
+            </a:r>
+          </a:p>
+          <a:p>
+            <a:r>
+              <a:t>Timing: ~20 min then discuss. Where they get stuck: they DESCRIBE YAT instead of ARGUING alignment —</a:t>
+            </a:r>
+          </a:p>
+          <a:p>
+            <a:r>
+              <a:t>circulate and push them to answer "which goal does this serve?"; also watch for uncited claims.</a:t>
+            </a:r>
+          </a:p>
+          <a:p>
+            <a:r>
+              <a:t>Share-back prompt: take two answers and ask the room which one traces to a real business objective.</a:t>
+            </a:r>
+          </a:p>
+          <a:p>
+            <a:r>
+              <a:t>No-leakage note: Ledgerline is the PRACTICE client — AT1 assesses the SAME skill on the LMS</a:t>
+            </a:r>
+          </a:p>
+          <a:p>
+            <a:r>
+              <a:t>(comparable, not identical); keep them on the scenario plan here.</a:t>
+            </a:r>
+          </a:p>
+        </p:txBody>
+      </p:sp>
+      <p:sp>
+        <p:nvSpPr>
+          <p:cNvPr id="4" name="Slide Number Placeholder 3"/>
+          <p:cNvSpPr>
+            <a:spLocks noGrp="1"/>
+          </p:cNvSpPr>
+          <p:nvPr>
+            <p:ph type="sldNum" idx="5" sz="quarter"/>
+          </p:nvPr>
+        </p:nvSpPr>
+        <p:spPr/>
+      </p:sp>
+    </p:spTree>
+  </p:cSld>
+  <p:clrMapOvr>
+    <a:masterClrMapping/>
+  </p:clrMapOvr>
+</p:notes>
+</file>
+
+<file path=ppt/notesSlides/notesSlide8.xml><?xml version="1.0" encoding="utf-8"?>
+<p:notes xmlns:a="http://schemas.openxmlformats.org/drawingml/2006/main" xmlns:p="http://schemas.openxmlformats.org/presentationml/2006/main" xmlns:r="http://schemas.openxmlformats.org/officeDocument/2006/relationships">
+  <p:cSld>
+    <p:spTree>
+      <p:nvGrpSpPr>
+        <p:cNvPr id="1" name=""/>
+        <p:cNvGrpSpPr/>
+        <p:nvPr/>
+      </p:nvGrpSpPr>
+      <p:grpSpPr>
+        <a:xfrm>
+          <a:off x="0" y="0"/>
+          <a:ext cx="0" cy="0"/>
+          <a:chOff x="0" y="0"/>
+          <a:chExt cx="0" cy="0"/>
+        </a:xfrm>
+      </p:grpSpPr>
+      <p:sp>
+        <p:nvSpPr>
+          <p:cNvPr id="2" name="Slide Image Placeholder 1"/>
+          <p:cNvSpPr>
+            <a:spLocks noGrp="1"/>
+          </p:cNvSpPr>
+          <p:nvPr>
+            <p:ph type="sldImg" idx="2"/>
+          </p:nvPr>
+        </p:nvSpPr>
+        <p:spPr/>
+      </p:sp>
+      <p:sp>
+        <p:nvSpPr>
+          <p:cNvPr id="3" name="Notes Placeholder 2"/>
+          <p:cNvSpPr>
+            <a:spLocks noGrp="1"/>
+          </p:cNvSpPr>
+          <p:nvPr>
+            <p:ph type="body" idx="3" sz="quarter"/>
+          </p:nvPr>
+        </p:nvSpPr>
+        <p:spPr/>
+        <p:txBody>
+          <a:bodyPr/>
+          <a:lstStyle/>
+          <a:p>
+            <a:r>
+              <a:t>Open Section 2 with its single governing idea — current state is SYNTHESIS, not a copy-paste of the</a:t>
+            </a:r>
+          </a:p>
+          <a:p>
+            <a:r>
+              <a:t>IT docs. This is the one thing students most often get wrong.</a:t>
+            </a:r>
+          </a:p>
+          <a:p>
+            <a:r>
+              <a:t>• First bullet: summarise the current environment IN YOUR OWN WORDS, focused on what's material to</a:t>
+            </a:r>
+          </a:p>
+          <a:p>
+            <a:r>
+              <a:t>  THIS decision.</a:t>
+            </a:r>
+          </a:p>
+          <a:p>
+            <a:r>
+              <a:t>• Second bullet: the board needs the picture that explains why change is needed — not a reproduction</a:t>
+            </a:r>
+          </a:p>
+          <a:p>
+            <a:r>
+              <a:t>  of the source documents.</a:t>
+            </a:r>
+          </a:p>
+          <a:p>
+            <a:r>
+              <a:t>• Third bullet (bolded): distil it down; don't transcribe it. Say the word "distil" out loud — it's</a:t>
+            </a:r>
+          </a:p>
+          <a:p>
+            <a:r>
+              <a:t>  the verb for the whole section.</a:t>
+            </a:r>
+          </a:p>
+          <a:p>
+            <a:r>
+              <a:t>Misconception to pre-empt: "thorough = paste everything in." No — a wall of copied specs is a FAIL of</a:t>
+            </a:r>
+          </a:p>
+          <a:p>
+            <a:r>
+              <a:t>synthesis; the skill is choosing and re-stating the material few in plain language.</a:t>
+            </a:r>
+          </a:p>
+          <a:p>
+            <a:r>
+              <a:t>Question to pose: "If the board can already read the IT docs, what's YOUR value in the current-state</a:t>
+            </a:r>
+          </a:p>
+          <a:p>
+            <a:r>
+              <a:t>section?" (you distil and interpret — you make it decision-relevant).</a:t>
+            </a:r>
+          </a:p>
+          <a:p>
+            <a:r>
+              <a:t>UoC/AT1 tie: PC 1.2 / PE 2 → AT1 §4 Current State (criterion A2); "own words, material only" is A2.</a:t>
+            </a:r>
+          </a:p>
+        </p:txBody>
+      </p:sp>
+      <p:sp>
+        <p:nvSpPr>
+          <p:cNvPr id="4" name="Slide Number Placeholder 3"/>
+          <p:cNvSpPr>
+            <a:spLocks noGrp="1"/>
+          </p:cNvSpPr>
+          <p:nvPr>
+            <p:ph type="sldNum" idx="5" sz="quarter"/>
+          </p:nvPr>
+        </p:nvSpPr>
+        <p:spPr/>
+      </p:sp>
+    </p:spTree>
+  </p:cSld>
+  <p:clrMapOvr>
+    <a:masterClrMapping/>
+  </p:clrMapOvr>
+</p:notes>
+</file>
+
+<file path=ppt/notesSlides/notesSlide9.xml><?xml version="1.0" encoding="utf-8"?>
+<p:notes xmlns:a="http://schemas.openxmlformats.org/drawingml/2006/main" xmlns:p="http://schemas.openxmlformats.org/presentationml/2006/main" xmlns:r="http://schemas.openxmlformats.org/officeDocument/2006/relationships">
+  <p:cSld>
+    <p:spTree>
+      <p:nvGrpSpPr>
+        <p:cNvPr id="1" name=""/>
+        <p:cNvGrpSpPr/>
+        <p:nvPr/>
+      </p:nvGrpSpPr>
+      <p:grpSpPr>
+        <a:xfrm>
+          <a:off x="0" y="0"/>
+          <a:ext cx="0" cy="0"/>
+          <a:chOff x="0" y="0"/>
+          <a:chExt cx="0" cy="0"/>
+        </a:xfrm>
+      </p:grpSpPr>
+      <p:sp>
+        <p:nvSpPr>
+          <p:cNvPr id="2" name="Slide Image Placeholder 1"/>
+          <p:cNvSpPr>
+            <a:spLocks noGrp="1"/>
+          </p:cNvSpPr>
+          <p:nvPr>
+            <p:ph type="sldImg" idx="2"/>
+          </p:nvPr>
+        </p:nvSpPr>
+        <p:spPr/>
+      </p:sp>
+      <p:sp>
+        <p:nvSpPr>
+          <p:cNvPr id="3" name="Notes Placeholder 2"/>
+          <p:cNvSpPr>
+            <a:spLocks noGrp="1"/>
+          </p:cNvSpPr>
+          <p:nvPr>
+            <p:ph type="body" idx="3" sz="quarter"/>
+          </p:nvPr>
+        </p:nvSpPr>
+        <p:spPr/>
+        <p:txBody>
+          <a:bodyPr/>
+          <a:lstStyle/>
+          <a:p>
+            <a:r>
+              <a:t>The how-to for Section 2 — teach the KEEP/DROP filter that separates material facts from noise.</a:t>
+            </a:r>
+          </a:p>
+          <a:p>
+            <a:r>
+              <a:t>• KEEP (if it bears on the decision): platform &amp; stack, age/condition/capacity, availability today,</a:t>
+            </a:r>
+          </a:p>
+          <a:p>
+            <a:r>
+              <a:t>  dependencies &amp; integrations, constraints, pain points. Read the list as "things that could change</a:t>
+            </a:r>
+          </a:p>
+          <a:p>
+            <a:r>
+              <a:t>  the renew-vs-migrate call".</a:t>
+            </a:r>
+          </a:p>
+          <a:p>
+            <a:r>
+              <a:t>• DROP: detail that doesn't move the decision — printer counts, unrelated systems.</a:t>
+            </a:r>
+          </a:p>
+          <a:p>
+            <a:r>
+              <a:t>• The sky-accent line: a good current state QUIETLY SURFACES the limitations that motivate the change</a:t>
+            </a:r>
+          </a:p>
+          <a:p>
+            <a:r>
+              <a:t>  — it sets up the gap analysis without shouting.</a:t>
+            </a:r>
+          </a:p>
+          <a:p>
+            <a:r>
+              <a:t>Misconception to pre-empt: "keep vs drop is about importance." No — it's about RELEVANCE TO THIS</a:t>
+            </a:r>
+          </a:p>
+          <a:p>
+            <a:r>
+              <a:t>DECISION; a fact can be true and important yet irrelevant to renew-vs-migrate, so it goes.</a:t>
+            </a:r>
+          </a:p>
+          <a:p>
+            <a:r>
+              <a:t>Question to pose: "The Ledgerline server is 6 years old and there are 12 office printers — which fact</a:t>
+            </a:r>
+          </a:p>
+          <a:p>
+            <a:r>
+              <a:t>do you keep, and why?" (age bears on renew-vs-migrate; printers don't).</a:t>
+            </a:r>
+          </a:p>
+          <a:p>
+            <a:r>
+              <a:t>UoC/AT1 tie: PC 1.2 / PE 2 → AT1 §4; the filter is how A2 stays material rather than a data dump.</a:t>
+            </a:r>
+          </a:p>
+        </p:txBody>
+      </p:sp>
+      <p:sp>
+        <p:nvSpPr>
+          <p:cNvPr id="4" name="Slide Number Placeholder 3"/>
+          <p:cNvSpPr>
+            <a:spLocks noGrp="1"/>
+          </p:cNvSpPr>
+          <p:nvPr>
+            <p:ph type="sldNum" idx="5" sz="quarter"/>
+          </p:nvPr>
+        </p:nvSpPr>
+        <p:spPr/>
+      </p:sp>
+    </p:spTree>
+  </p:cSld>
+  <p:clrMapOvr>
+    <a:masterClrMapping/>
+  </p:clrMapOvr>
+</p:notes>
 </file>
 
 <file path=ppt/slideLayouts/slideLayout1.xml><?xml version="1.0" encoding="utf-8"?>
@@ -13694,4 +15769,324 @@
   </a:objectDefaults>
   <a:extraClrSchemeLst/>
 </a:theme>
+</file>
+
+<file path=ppt/theme/theme2.xml><?xml version="1.0" encoding="utf-8"?>
+<a:theme xmlns:a="http://schemas.openxmlformats.org/drawingml/2006/main" name="Office Theme">
+  <a:themeElements>
+    <a:clrScheme name="Office">
+      <a:dk1>
+        <a:sysClr val="windowText" lastClr="000000"/>
+      </a:dk1>
+      <a:lt1>
+        <a:sysClr val="window" lastClr="FFFFFF"/>
+      </a:lt1>
+      <a:dk2>
+        <a:srgbClr val="1F497D"/>
+      </a:dk2>
+      <a:lt2>
+        <a:srgbClr val="EEECE1"/>
+      </a:lt2>
+      <a:accent1>
+        <a:srgbClr val="4F81BD"/>
+      </a:accent1>
+      <a:accent2>
+        <a:srgbClr val="C0504D"/>
+      </a:accent2>
+      <a:accent3>
+        <a:srgbClr val="9BBB59"/>
+      </a:accent3>
+      <a:accent4>
+        <a:srgbClr val="8064A2"/>
+      </a:accent4>
+      <a:accent5>
+        <a:srgbClr val="4BACC6"/>
+      </a:accent5>
+      <a:accent6>
+        <a:srgbClr val="F79646"/>
+      </a:accent6>
+      <a:hlink>
+        <a:srgbClr val="0000FF"/>
+      </a:hlink>
+      <a:folHlink>
+        <a:srgbClr val="800080"/>
+      </a:folHlink>
+    </a:clrScheme>
+    <a:fontScheme name="Office">
+      <a:majorFont>
+        <a:latin typeface="Calibri"/>
+        <a:ea typeface=""/>
+        <a:cs typeface=""/>
+        <a:font script="Jpan" typeface="ＭＳ Ｐゴシック"/>
+        <a:font script="Hang" typeface="맑은 고딕"/>
+        <a:font script="Hans" typeface="宋体"/>
+        <a:font script="Hant" typeface="新細明體"/>
+        <a:font script="Arab" typeface="Times New Roman"/>
+        <a:font script="Hebr" typeface="Times New Roman"/>
+        <a:font script="Thai" typeface="Angsana New"/>
+        <a:font script="Ethi" typeface="Nyala"/>
+        <a:font script="Beng" typeface="Vrinda"/>
+        <a:font script="Gujr" typeface="Shruti"/>
+        <a:font script="Khmr" typeface="MoolBoran"/>
+        <a:font script="Knda" typeface="Tunga"/>
+        <a:font script="Guru" typeface="Raavi"/>
+        <a:font script="Cans" typeface="Euphemia"/>
+        <a:font script="Cher" typeface="Plantagenet Cherokee"/>
+        <a:font script="Yiii" typeface="Microsoft Yi Baiti"/>
+        <a:font script="Tibt" typeface="Microsoft Himalaya"/>
+        <a:font script="Thaa" typeface="MV Boli"/>
+        <a:font script="Deva" typeface="Mangal"/>
+        <a:font script="Telu" typeface="Gautami"/>
+        <a:font script="Taml" typeface="Latha"/>
+        <a:font script="Syrc" typeface="Estrangelo Edessa"/>
+        <a:font script="Orya" typeface="Kalinga"/>
+        <a:font script="Mlym" typeface="Kartika"/>
+        <a:font script="Laoo" typeface="DokChampa"/>
+        <a:font script="Sinh" typeface="Iskoola Pota"/>
+        <a:font script="Mong" typeface="Mongolian Baiti"/>
+        <a:font script="Viet" typeface="Times New Roman"/>
+        <a:font script="Uigh" typeface="Microsoft Uighur"/>
+        <a:font script="Geor" typeface="Sylfaen"/>
+      </a:majorFont>
+      <a:minorFont>
+        <a:latin typeface="Calibri"/>
+        <a:ea typeface=""/>
+        <a:cs typeface=""/>
+        <a:font script="Jpan" typeface="ＭＳ Ｐゴシック"/>
+        <a:font script="Hang" typeface="맑은 고딕"/>
+        <a:font script="Hans" typeface="宋体"/>
+        <a:font script="Hant" typeface="新細明體"/>
+        <a:font script="Arab" typeface="Arial"/>
+        <a:font script="Hebr" typeface="Arial"/>
+        <a:font script="Thai" typeface="Cordia New"/>
+        <a:font script="Ethi" typeface="Nyala"/>
+        <a:font script="Beng" typeface="Vrinda"/>
+        <a:font script="Gujr" typeface="Shruti"/>
+        <a:font script="Khmr" typeface="DaunPenh"/>
+        <a:font script="Knda" typeface="Tunga"/>
+        <a:font script="Guru" typeface="Raavi"/>
+        <a:font script="Cans" typeface="Euphemia"/>
+        <a:font script="Cher" typeface="Plantagenet Cherokee"/>
+        <a:font script="Yiii" typeface="Microsoft Yi Baiti"/>
+        <a:font script="Tibt" typeface="Microsoft Himalaya"/>
+        <a:font script="Thaa" typeface="MV Boli"/>
+        <a:font script="Deva" typeface="Mangal"/>
+        <a:font script="Telu" typeface="Gautami"/>
+        <a:font script="Taml" typeface="Latha"/>
+        <a:font script="Syrc" typeface="Estrangelo Edessa"/>
+        <a:font script="Orya" typeface="Kalinga"/>
+        <a:font script="Mlym" typeface="Kartika"/>
+        <a:font script="Laoo" typeface="DokChampa"/>
+        <a:font script="Sinh" typeface="Iskoola Pota"/>
+        <a:font script="Mong" typeface="Mongolian Baiti"/>
+        <a:font script="Viet" typeface="Arial"/>
+        <a:font script="Uigh" typeface="Microsoft Uighur"/>
+        <a:font script="Geor" typeface="Sylfaen"/>
+      </a:minorFont>
+    </a:fontScheme>
+    <a:fmtScheme name="Office">
+      <a:fillStyleLst>
+        <a:solidFill>
+          <a:schemeClr val="phClr"/>
+        </a:solidFill>
+        <a:gradFill rotWithShape="1">
+          <a:gsLst>
+            <a:gs pos="0">
+              <a:schemeClr val="phClr">
+                <a:tint val="50000"/>
+                <a:satMod val="300000"/>
+              </a:schemeClr>
+            </a:gs>
+            <a:gs pos="35000">
+              <a:schemeClr val="phClr">
+                <a:tint val="37000"/>
+                <a:satMod val="300000"/>
+              </a:schemeClr>
+            </a:gs>
+            <a:gs pos="100000">
+              <a:schemeClr val="phClr">
+                <a:tint val="15000"/>
+                <a:satMod val="350000"/>
+              </a:schemeClr>
+            </a:gs>
+          </a:gsLst>
+          <a:lin ang="16200000" scaled="1"/>
+        </a:gradFill>
+        <a:gradFill rotWithShape="1">
+          <a:gsLst>
+            <a:gs pos="0">
+              <a:schemeClr val="phClr">
+                <a:tint val="100000"/>
+                <a:shade val="100000"/>
+                <a:satMod val="130000"/>
+              </a:schemeClr>
+            </a:gs>
+            <a:gs pos="100000">
+              <a:schemeClr val="phClr">
+                <a:tint val="50000"/>
+                <a:shade val="100000"/>
+                <a:satMod val="350000"/>
+              </a:schemeClr>
+            </a:gs>
+          </a:gsLst>
+          <a:lin ang="16200000" scaled="0"/>
+        </a:gradFill>
+      </a:fillStyleLst>
+      <a:lnStyleLst>
+        <a:ln w="9525" cap="flat" cmpd="sng" algn="ctr">
+          <a:solidFill>
+            <a:schemeClr val="phClr">
+              <a:shade val="95000"/>
+              <a:satMod val="105000"/>
+            </a:schemeClr>
+          </a:solidFill>
+          <a:prstDash val="solid"/>
+        </a:ln>
+        <a:ln w="25400" cap="flat" cmpd="sng" algn="ctr">
+          <a:solidFill>
+            <a:schemeClr val="phClr"/>
+          </a:solidFill>
+          <a:prstDash val="solid"/>
+        </a:ln>
+        <a:ln w="38100" cap="flat" cmpd="sng" algn="ctr">
+          <a:solidFill>
+            <a:schemeClr val="phClr"/>
+          </a:solidFill>
+          <a:prstDash val="solid"/>
+        </a:ln>
+      </a:lnStyleLst>
+      <a:effectStyleLst>
+        <a:effectStyle>
+          <a:effectLst>
+            <a:outerShdw blurRad="40000" dist="20000" dir="5400000" rotWithShape="0">
+              <a:srgbClr val="000000">
+                <a:alpha val="38000"/>
+              </a:srgbClr>
+            </a:outerShdw>
+          </a:effectLst>
+        </a:effectStyle>
+        <a:effectStyle>
+          <a:effectLst>
+            <a:outerShdw blurRad="40000" dist="23000" dir="5400000" rotWithShape="0">
+              <a:srgbClr val="000000">
+                <a:alpha val="35000"/>
+              </a:srgbClr>
+            </a:outerShdw>
+          </a:effectLst>
+        </a:effectStyle>
+        <a:effectStyle>
+          <a:effectLst>
+            <a:outerShdw blurRad="40000" dist="23000" dir="5400000" rotWithShape="0">
+              <a:srgbClr val="000000">
+                <a:alpha val="35000"/>
+              </a:srgbClr>
+            </a:outerShdw>
+          </a:effectLst>
+          <a:scene3d>
+            <a:camera prst="orthographicFront">
+              <a:rot lat="0" lon="0" rev="0"/>
+            </a:camera>
+            <a:lightRig rig="threePt" dir="t">
+              <a:rot lat="0" lon="0" rev="1200000"/>
+            </a:lightRig>
+          </a:scene3d>
+          <a:sp3d>
+            <a:bevelT w="63500" h="25400"/>
+          </a:sp3d>
+        </a:effectStyle>
+      </a:effectStyleLst>
+      <a:bgFillStyleLst>
+        <a:solidFill>
+          <a:schemeClr val="phClr"/>
+        </a:solidFill>
+        <a:gradFill rotWithShape="1">
+          <a:gsLst>
+            <a:gs pos="0">
+              <a:schemeClr val="phClr">
+                <a:tint val="40000"/>
+                <a:satMod val="350000"/>
+              </a:schemeClr>
+            </a:gs>
+            <a:gs pos="40000">
+              <a:schemeClr val="phClr">
+                <a:tint val="45000"/>
+                <a:shade val="99000"/>
+                <a:satMod val="350000"/>
+              </a:schemeClr>
+            </a:gs>
+            <a:gs pos="100000">
+              <a:schemeClr val="phClr">
+                <a:shade val="20000"/>
+                <a:satMod val="255000"/>
+              </a:schemeClr>
+            </a:gs>
+          </a:gsLst>
+          <a:path path="circle">
+            <a:fillToRect l="50000" t="-80000" r="50000" b="180000"/>
+          </a:path>
+        </a:gradFill>
+        <a:gradFill rotWithShape="1">
+          <a:gsLst>
+            <a:gs pos="0">
+              <a:schemeClr val="phClr">
+                <a:tint val="80000"/>
+                <a:satMod val="300000"/>
+              </a:schemeClr>
+            </a:gs>
+            <a:gs pos="100000">
+              <a:schemeClr val="phClr">
+                <a:shade val="30000"/>
+                <a:satMod val="200000"/>
+              </a:schemeClr>
+            </a:gs>
+          </a:gsLst>
+          <a:path path="circle">
+            <a:fillToRect l="50000" t="50000" r="50000" b="50000"/>
+          </a:path>
+        </a:gradFill>
+      </a:bgFillStyleLst>
+    </a:fmtScheme>
+  </a:themeElements>
+  <a:objectDefaults>
+    <a:spDef>
+      <a:spPr/>
+      <a:bodyPr/>
+      <a:lstStyle/>
+      <a:style>
+        <a:lnRef idx="1">
+          <a:schemeClr val="accent1"/>
+        </a:lnRef>
+        <a:fillRef idx="3">
+          <a:schemeClr val="accent1"/>
+        </a:fillRef>
+        <a:effectRef idx="2">
+          <a:schemeClr val="accent1"/>
+        </a:effectRef>
+        <a:fontRef idx="minor">
+          <a:schemeClr val="lt1"/>
+        </a:fontRef>
+      </a:style>
+    </a:spDef>
+    <a:lnDef>
+      <a:spPr/>
+      <a:bodyPr/>
+      <a:lstStyle/>
+      <a:style>
+        <a:lnRef idx="2">
+          <a:schemeClr val="accent1"/>
+        </a:lnRef>
+        <a:fillRef idx="0">
+          <a:schemeClr val="accent1"/>
+        </a:fillRef>
+        <a:effectRef idx="1">
+          <a:schemeClr val="accent1"/>
+        </a:effectRef>
+        <a:fontRef idx="minor">
+          <a:schemeClr val="tx1"/>
+        </a:fontRef>
+      </a:style>
+    </a:lnDef>
+  </a:objectDefaults>
+  <a:extraClrSchemeLst/>
+</a:theme>
 </file>
</xml_diff>

<commit_message>
delivery(CL1): migrate all 14 topic decks to the generic slide-plan builder
- CL1 now builds from content-complete slide_plan.md via build_topic_deck.py
  (like CL2/CL3); retire the 15 per-topic build scripts + 15 topicNN_notes.py
- decks rebuilt in place; each reproduces its prior committed deck (body+notes+
  images) except two accepted standardisations: topic_01 gains its missing
  section-1 divider; topic_08b dividers renumber 01/02->03/04
- topic_08 (1 coverage <-> 2 decks) split into slide_plan_08a.md / _08b.md,
  each declaring Covers-components; notes now live as notes: blocks in the plans

Co-Authored-By: Claude Opus 4.8 (1M context) <noreply@anthropic.com>
</commit_message>
<xml_diff>
--- a/S1-CL1-Cloud-Design-Build/delivery/topic_02/Topic_02_Slides.pptx
+++ b/S1-CL1-Cloud-Design-Build/delivery/topic_02/Topic_02_Slides.pptx
@@ -539,7 +539,7 @@
           </a:p>
           <a:p>
             <a:r>
-              <a:t>  organisation is, where it needs to be, and the gap between. No solutions yet.</a:t>
+              <a:t>organisation is, where it needs to be, and the gap between. No solutions yet.</a:t>
             </a:r>
           </a:p>
           <a:p>
@@ -549,7 +549,7 @@
           </a:p>
           <a:p>
             <a:r>
-              <a:t>  you plot a route.</a:t>
+              <a:t>you plot a route.</a:t>
             </a:r>
           </a:p>
           <a:p>
@@ -559,7 +559,7 @@
           </a:p>
           <a:p>
             <a:r>
-              <a:t>  the gaps. Say them in that order; each depends on the one before.</a:t>
+              <a:t>the gaps. Say them in that order; each depends on the one before.</a:t>
             </a:r>
           </a:p>
           <a:p>
@@ -569,7 +569,7 @@
           </a:p>
           <a:p>
             <a:r>
-              <a:t>  they build today is directly the front half of the AT1 deliverable.</a:t>
+              <a:t>they build today is directly the front half of the AT1 deliverable.</a:t>
             </a:r>
           </a:p>
           <a:p>
@@ -684,7 +684,7 @@
           </a:p>
           <a:p>
             <a:r>
-              <a:t>  the relevance filter applied).</a:t>
+              <a:t>the relevance filter applied).</a:t>
             </a:r>
           </a:p>
           <a:p>
@@ -694,7 +694,7 @@
           </a:p>
           <a:p>
             <a:r>
-              <a:t>  condition-risk. Grouping is what makes it read as synthesis, not a list.</a:t>
+              <a:t>condition-risk. Grouping is what makes it read as synthesis, not a list.</a:t>
             </a:r>
           </a:p>
           <a:p>
@@ -824,7 +824,7 @@
           </a:p>
           <a:p>
             <a:r>
-              <a:t>   Overview, and the consultation notes on the scenario intranet.</a:t>
+              <a:t>Overview, and the consultation notes on the scenario intranet.</a:t>
             </a:r>
           </a:p>
           <a:p>
@@ -834,7 +834,7 @@
           </a:p>
           <a:p>
             <a:r>
-              <a:t>   fee-status, payroll, banking) · condition &amp; constraints.</a:t>
+              <a:t>fee-status, payroll, banking) · condition &amp; constraints.</a:t>
             </a:r>
           </a:p>
           <a:p>
@@ -959,7 +959,7 @@
           </a:p>
           <a:p>
             <a:r>
-              <a:t>  current state) — it literally joins §3 to §4.</a:t>
+              <a:t>current state) — it literally joins §3 to §4.</a:t>
             </a:r>
           </a:p>
           <a:p>
@@ -969,7 +969,7 @@
           </a:p>
           <a:p>
             <a:r>
-              <a:t>  list of changes to evaluate (the seed of Topic 3's options).</a:t>
+              <a:t>list of changes to evaluate (the seed of Topic 3's options).</a:t>
             </a:r>
           </a:p>
           <a:p>
@@ -1104,17 +1104,17 @@
           </a:p>
           <a:p>
             <a:r>
-              <a:t>   in-house infrastructure dependency (ageing server); business-hours availability &gt;=99.5% (RPO &lt;=1h /</a:t>
-            </a:r>
-          </a:p>
-          <a:p>
-            <a:r>
-              <a:t>   RTO &lt;=1 business day); keep financial data onshore + 7-year retention; size for month-end / EOFY</a:t>
-            </a:r>
-          </a:p>
-          <a:p>
-            <a:r>
-              <a:t>   peaks without year-round over-provisioning.</a:t>
+              <a:t>in-house infrastructure dependency (ageing server); business-hours availability &gt;=99.5% (RPO &lt;=1h /</a:t>
+            </a:r>
+          </a:p>
+          <a:p>
+            <a:r>
+              <a:t>RTO &lt;=1 business day); keep financial data onshore + 7-year retention; size for month-end / EOFY</a:t>
+            </a:r>
+          </a:p>
+          <a:p>
+            <a:r>
+              <a:t>peaks without year-round over-provisioning.</a:t>
             </a:r>
           </a:p>
           <a:p>
@@ -1244,7 +1244,7 @@
           </a:p>
           <a:p>
             <a:r>
-              <a:t>  (current state) → what's missing to get there (gaps). Each answer feeds the next.</a:t>
+              <a:t>(current state) → what's missing to get there (gaps). Each answer feeds the next.</a:t>
             </a:r>
           </a:p>
           <a:p>
@@ -1254,7 +1254,7 @@
           </a:p>
           <a:p>
             <a:r>
-              <a:t>  is real and worth solving. "Diagnose before you prescribe" (the magenta line) is the Topic's motto.</a:t>
+              <a:t>is real and worth solving. "Diagnose before you prescribe" (the magenta line) is the Topic's motto.</a:t>
             </a:r>
           </a:p>
           <a:p>
@@ -1359,7 +1359,7 @@
           </a:p>
           <a:p>
             <a:r>
-              <a:t>  so you lead by showing the initiative serves the strategy, not technology for its own sake.</a:t>
+              <a:t>so you lead by showing the initiative serves the strategy, not technology for its own sake.</a:t>
             </a:r>
           </a:p>
           <a:p>
@@ -1369,7 +1369,7 @@
           </a:p>
           <a:p>
             <a:r>
-              <a:t>  this delivers it." It's an argument, not a description.</a:t>
+              <a:t>this delivers it." It's an argument, not a description.</a:t>
             </a:r>
           </a:p>
           <a:p>
@@ -1379,7 +1379,7 @@
           </a:p>
           <a:p>
             <a:r>
-              <a:t>  tie the initiative to a stated goal, the case is already weak.</a:t>
+              <a:t>tie the initiative to a stated goal, the case is already weak.</a:t>
             </a:r>
           </a:p>
           <a:p>
@@ -1489,12 +1489,12 @@
           </a:p>
           <a:p>
             <a:r>
-              <a:t>  15%/yr) → ICT goals (how ICT supports that, e.g. reduce in-house dependency, 99.9% for critical</a:t>
-            </a:r>
-          </a:p>
-          <a:p>
-            <a:r>
-              <a:t>  systems) → initiatives (the planned actions, e.g. move suitable systems to cloud).</a:t>
+              <a:t>15%/yr) → ICT goals (how ICT supports that, e.g. reduce in-house dependency, 99.9% for critical</a:t>
+            </a:r>
+          </a:p>
+          <a:p>
+            <a:r>
+              <a:t>systems) → initiatives (the planned actions, e.g. move suitable systems to cloud).</a:t>
             </a:r>
           </a:p>
           <a:p>
@@ -1504,7 +1504,7 @@
           </a:p>
           <a:p>
             <a:r>
-              <a:t>  pull only what's MATERIAL — don't recite the whole plan.</a:t>
+              <a:t>pull only what's MATERIAL — don't recite the whole plan.</a:t>
             </a:r>
           </a:p>
           <a:p>
@@ -1619,7 +1619,7 @@
           </a:p>
           <a:p>
             <a:r>
-              <a:t>  resilience. These are the yardsticks.</a:t>
+              <a:t>resilience. These are the yardsticks.</a:t>
             </a:r>
           </a:p>
           <a:p>
@@ -1629,7 +1629,7 @@
           </a:p>
           <a:p>
             <a:r>
-              <a:t>  strengthens the case) and divergence (plan lags or differs → a risk, or an opportunity to flag).</a:t>
+              <a:t>strengthens the case) and divergence (plan lags or differs → a risk, or an opportunity to flag).</a:t>
             </a:r>
           </a:p>
           <a:p>
@@ -2009,7 +2009,7 @@
           </a:p>
           <a:p>
             <a:r>
-              <a:t>  THIS decision.</a:t>
+              <a:t>THIS decision.</a:t>
             </a:r>
           </a:p>
           <a:p>
@@ -2019,7 +2019,7 @@
           </a:p>
           <a:p>
             <a:r>
-              <a:t>  of the source documents.</a:t>
+              <a:t>of the source documents.</a:t>
             </a:r>
           </a:p>
           <a:p>
@@ -2029,7 +2029,7 @@
           </a:p>
           <a:p>
             <a:r>
-              <a:t>  the verb for the whole section.</a:t>
+              <a:t>the verb for the whole section.</a:t>
             </a:r>
           </a:p>
           <a:p>
@@ -2134,12 +2134,12 @@
           </a:p>
           <a:p>
             <a:r>
-              <a:t>  dependencies &amp; integrations, constraints, pain points. Read the list as "things that could change</a:t>
-            </a:r>
-          </a:p>
-          <a:p>
-            <a:r>
-              <a:t>  the renew-vs-migrate call".</a:t>
+              <a:t>dependencies &amp; integrations, constraints, pain points. Read the list as "things that could change</a:t>
+            </a:r>
+          </a:p>
+          <a:p>
+            <a:r>
+              <a:t>the renew-vs-migrate call".</a:t>
             </a:r>
           </a:p>
           <a:p>
@@ -2154,7 +2154,7 @@
           </a:p>
           <a:p>
             <a:r>
-              <a:t>  — it sets up the gap analysis without shouting.</a:t>
+              <a:t>— it sets up the gap analysis without shouting.</a:t>
             </a:r>
           </a:p>
           <a:p>
@@ -6605,9 +6605,9 @@
               <a:t>■  </a:t>
             </a:r>
             <a:r>
-              <a:rPr sz="2400" b="1" i="0">
-                <a:solidFill>
-                  <a:srgbClr val="D68E10"/>
+              <a:rPr sz="2400" b="0" i="0">
+                <a:solidFill>
+                  <a:srgbClr val="2A2929"/>
                 </a:solidFill>
                 <a:latin typeface="Roboto"/>
               </a:rPr>
@@ -6901,7 +6901,7 @@
               <a:t>■  </a:t>
             </a:r>
             <a:r>
-              <a:rPr sz="2400" b="1" i="0">
+              <a:rPr sz="2400" b="0" i="0">
                 <a:solidFill>
                   <a:srgbClr val="2A2929"/>
                 </a:solidFill>
@@ -6963,7 +6963,7 @@
               <a:t>■  </a:t>
             </a:r>
             <a:r>
-              <a:rPr sz="2400" b="1" i="0">
+              <a:rPr sz="2400" b="0" i="0">
                 <a:solidFill>
                   <a:srgbClr val="2A2929"/>
                 </a:solidFill>
@@ -7018,16 +7018,16 @@
             <a:r>
               <a:rPr sz="2400" b="1" i="0">
                 <a:solidFill>
-                  <a:srgbClr val="27B5CE"/>
+                  <a:srgbClr val="EDAB0C"/>
                 </a:solidFill>
                 <a:latin typeface="Roboto"/>
               </a:rPr>
               <a:t>■  </a:t>
             </a:r>
             <a:r>
-              <a:rPr sz="2400" b="1" i="0">
-                <a:solidFill>
-                  <a:srgbClr val="27B5CE"/>
+              <a:rPr sz="2400" b="0" i="0">
+                <a:solidFill>
+                  <a:srgbClr val="2A2929"/>
                 </a:solidFill>
                 <a:latin typeface="Roboto"/>
               </a:rPr>
@@ -7398,9 +7398,9 @@
               <a:t>■  </a:t>
             </a:r>
             <a:r>
-              <a:rPr sz="2400" b="1" i="0">
-                <a:solidFill>
-                  <a:srgbClr val="D68E10"/>
+              <a:rPr sz="2400" b="0" i="0">
+                <a:solidFill>
+                  <a:srgbClr val="2A2929"/>
                 </a:solidFill>
                 <a:latin typeface="Roboto"/>
               </a:rPr>
@@ -7731,7 +7731,7 @@
               <a:t>■  </a:t>
             </a:r>
             <a:r>
-              <a:rPr sz="1700" b="1" i="0">
+              <a:rPr sz="1700" b="0" i="0">
                 <a:solidFill>
                   <a:srgbClr val="2A2929"/>
                 </a:solidFill>
@@ -7879,7 +7879,7 @@
             <a:r>
               <a:rPr sz="1700" b="1" i="0">
                 <a:solidFill>
-                  <a:srgbClr val="27B5CE"/>
+                  <a:srgbClr val="EDAB0C"/>
                 </a:solidFill>
                 <a:latin typeface="Roboto"/>
               </a:rPr>
@@ -7888,7 +7888,7 @@
             <a:r>
               <a:rPr sz="1700" b="0" i="0">
                 <a:solidFill>
-                  <a:srgbClr val="27B5CE"/>
+                  <a:srgbClr val="2A2929"/>
                 </a:solidFill>
                 <a:latin typeface="Roboto"/>
               </a:rPr>
@@ -9253,16 +9253,16 @@
             <a:r>
               <a:rPr sz="2400" b="1" i="0">
                 <a:solidFill>
-                  <a:srgbClr val="205F61"/>
+                  <a:srgbClr val="EDAB0C"/>
                 </a:solidFill>
                 <a:latin typeface="Roboto"/>
               </a:rPr>
               <a:t>■  </a:t>
             </a:r>
             <a:r>
-              <a:rPr sz="2400" b="1" i="0">
-                <a:solidFill>
-                  <a:srgbClr val="205F61"/>
+              <a:rPr sz="2400" b="0" i="0">
+                <a:solidFill>
+                  <a:srgbClr val="2A2929"/>
                 </a:solidFill>
                 <a:latin typeface="Roboto"/>
               </a:rPr>
@@ -9523,7 +9523,7 @@
         </p:nvGraphicFramePr>
         <p:xfrm>
           <a:off x="658368" y="1828800"/>
-          <a:ext cx="10881360" cy="914400"/>
+          <a:ext cx="10881360" cy="457200"/>
         </p:xfrm>
         <a:graphic>
           <a:graphicData uri="http://schemas.openxmlformats.org/drawingml/2006/table">
@@ -9532,12 +9532,12 @@
                 <a:tableStyleId>{5C22544A-7EE6-4342-B048-85BDC9FD1C3A}</a:tableStyleId>
               </a:tblPr>
               <a:tblGrid>
-                <a:gridCol w="2011680"/>
-                <a:gridCol w="1828800"/>
-                <a:gridCol w="1737360"/>
-                <a:gridCol w="1737360"/>
-                <a:gridCol w="1737360"/>
-                <a:gridCol w="1828800"/>
+                <a:gridCol w="1813560"/>
+                <a:gridCol w="1813560"/>
+                <a:gridCol w="1813560"/>
+                <a:gridCol w="1813560"/>
+                <a:gridCol w="1813560"/>
+                <a:gridCol w="1813560"/>
               </a:tblGrid>
               <a:tr h="457200">
                 <a:tc>
@@ -9673,140 +9673,6 @@
                   </a:tcPr>
                 </a:tc>
               </a:tr>
-              <a:tr h="457200">
-                <a:tc>
-                  <a:txBody>
-                    <a:bodyPr/>
-                    <a:lstStyle/>
-                    <a:p>
-                      <a:r>
-                        <a:rPr sz="1300" b="0" i="0">
-                          <a:solidFill>
-                            <a:srgbClr val="2A2929"/>
-                          </a:solidFill>
-                          <a:latin typeface="Roboto"/>
-                        </a:rPr>
-                        <a:t/>
-                      </a:r>
-                    </a:p>
-                  </a:txBody>
-                  <a:tcPr marL="76200" marR="76200" marT="50800" marB="50800">
-                    <a:solidFill>
-                      <a:srgbClr val="FFFFFF"/>
-                    </a:solidFill>
-                  </a:tcPr>
-                </a:tc>
-                <a:tc>
-                  <a:txBody>
-                    <a:bodyPr/>
-                    <a:lstStyle/>
-                    <a:p>
-                      <a:r>
-                        <a:rPr sz="1300" b="0" i="0">
-                          <a:solidFill>
-                            <a:srgbClr val="2A2929"/>
-                          </a:solidFill>
-                          <a:latin typeface="Roboto"/>
-                        </a:rPr>
-                        <a:t/>
-                      </a:r>
-                    </a:p>
-                  </a:txBody>
-                  <a:tcPr marL="76200" marR="76200" marT="50800" marB="50800">
-                    <a:solidFill>
-                      <a:srgbClr val="FFFFFF"/>
-                    </a:solidFill>
-                  </a:tcPr>
-                </a:tc>
-                <a:tc>
-                  <a:txBody>
-                    <a:bodyPr/>
-                    <a:lstStyle/>
-                    <a:p>
-                      <a:r>
-                        <a:rPr sz="1300" b="0" i="0">
-                          <a:solidFill>
-                            <a:srgbClr val="2A2929"/>
-                          </a:solidFill>
-                          <a:latin typeface="Roboto"/>
-                        </a:rPr>
-                        <a:t/>
-                      </a:r>
-                    </a:p>
-                  </a:txBody>
-                  <a:tcPr marL="76200" marR="76200" marT="50800" marB="50800">
-                    <a:solidFill>
-                      <a:srgbClr val="FFFFFF"/>
-                    </a:solidFill>
-                  </a:tcPr>
-                </a:tc>
-                <a:tc>
-                  <a:txBody>
-                    <a:bodyPr/>
-                    <a:lstStyle/>
-                    <a:p>
-                      <a:r>
-                        <a:rPr sz="1300" b="0" i="0">
-                          <a:solidFill>
-                            <a:srgbClr val="2A2929"/>
-                          </a:solidFill>
-                          <a:latin typeface="Roboto"/>
-                        </a:rPr>
-                        <a:t/>
-                      </a:r>
-                    </a:p>
-                  </a:txBody>
-                  <a:tcPr marL="76200" marR="76200" marT="50800" marB="50800">
-                    <a:solidFill>
-                      <a:srgbClr val="FFFFFF"/>
-                    </a:solidFill>
-                  </a:tcPr>
-                </a:tc>
-                <a:tc>
-                  <a:txBody>
-                    <a:bodyPr/>
-                    <a:lstStyle/>
-                    <a:p>
-                      <a:r>
-                        <a:rPr sz="1300" b="0" i="0">
-                          <a:solidFill>
-                            <a:srgbClr val="2A2929"/>
-                          </a:solidFill>
-                          <a:latin typeface="Roboto"/>
-                        </a:rPr>
-                        <a:t/>
-                      </a:r>
-                    </a:p>
-                  </a:txBody>
-                  <a:tcPr marL="76200" marR="76200" marT="50800" marB="50800">
-                    <a:solidFill>
-                      <a:srgbClr val="FFFFFF"/>
-                    </a:solidFill>
-                  </a:tcPr>
-                </a:tc>
-                <a:tc>
-                  <a:txBody>
-                    <a:bodyPr/>
-                    <a:lstStyle/>
-                    <a:p>
-                      <a:r>
-                        <a:rPr sz="1300" b="0" i="0">
-                          <a:solidFill>
-                            <a:srgbClr val="2A2929"/>
-                          </a:solidFill>
-                          <a:latin typeface="Roboto"/>
-                        </a:rPr>
-                        <a:t/>
-                      </a:r>
-                    </a:p>
-                  </a:txBody>
-                  <a:tcPr marL="76200" marR="76200" marT="50800" marB="50800">
-                    <a:solidFill>
-                      <a:srgbClr val="FFFFFF"/>
-                    </a:solidFill>
-                  </a:tcPr>
-                </a:tc>
-              </a:tr>
             </a:tbl>
           </a:graphicData>
         </a:graphic>
@@ -10192,9 +10058,9 @@
               <a:t>■  </a:t>
             </a:r>
             <a:r>
-              <a:rPr sz="2400" b="1" i="0">
-                <a:solidFill>
-                  <a:srgbClr val="D68E10"/>
+              <a:rPr sz="2400" b="0" i="0">
+                <a:solidFill>
+                  <a:srgbClr val="2A2929"/>
                 </a:solidFill>
                 <a:latin typeface="Roboto"/>
               </a:rPr>
@@ -10495,8 +10361,8 @@
                 <a:tableStyleId>{5C22544A-7EE6-4342-B048-85BDC9FD1C3A}</a:tableStyleId>
               </a:tblPr>
               <a:tblGrid>
-                <a:gridCol w="2377440"/>
-                <a:gridCol w="8503920"/>
+                <a:gridCol w="5440680"/>
+                <a:gridCol w="5440680"/>
               </a:tblGrid>
               <a:tr h="457200">
                 <a:tc>
@@ -11180,7 +11046,7 @@
               <a:t>■  </a:t>
             </a:r>
             <a:r>
-              <a:rPr sz="1700" b="1" i="0">
+              <a:rPr sz="1700" b="0" i="0">
                 <a:solidFill>
                   <a:srgbClr val="2A2929"/>
                 </a:solidFill>
@@ -11390,7 +11256,7 @@
             <a:r>
               <a:rPr sz="1700" b="1" i="0">
                 <a:solidFill>
-                  <a:srgbClr val="205F61"/>
+                  <a:srgbClr val="EDAB0C"/>
                 </a:solidFill>
                 <a:latin typeface="Roboto"/>
               </a:rPr>
@@ -11399,7 +11265,7 @@
             <a:r>
               <a:rPr sz="1700" b="0" i="0">
                 <a:solidFill>
-                  <a:srgbClr val="205F61"/>
+                  <a:srgbClr val="2A2929"/>
                 </a:solidFill>
                 <a:latin typeface="Roboto"/>
               </a:rPr>
@@ -12733,16 +12599,16 @@
             <a:r>
               <a:rPr sz="2400" b="1" i="0">
                 <a:solidFill>
-                  <a:srgbClr val="92268F"/>
+                  <a:srgbClr val="EDAB0C"/>
                 </a:solidFill>
                 <a:latin typeface="Roboto"/>
               </a:rPr>
               <a:t>■  </a:t>
             </a:r>
             <a:r>
-              <a:rPr sz="2400" b="1" i="0">
-                <a:solidFill>
-                  <a:srgbClr val="92268F"/>
+              <a:rPr sz="2400" b="0" i="0">
+                <a:solidFill>
+                  <a:srgbClr val="2A2929"/>
                 </a:solidFill>
                 <a:latin typeface="Roboto"/>
               </a:rPr>
@@ -13421,9 +13287,9 @@
               <a:t>■  </a:t>
             </a:r>
             <a:r>
-              <a:rPr sz="2400" b="1" i="0">
-                <a:solidFill>
-                  <a:srgbClr val="D68E10"/>
+              <a:rPr sz="2400" b="0" i="0">
+                <a:solidFill>
+                  <a:srgbClr val="2A2929"/>
                 </a:solidFill>
                 <a:latin typeface="Roboto"/>
               </a:rPr>
@@ -13701,7 +13567,7 @@
               <a:t>■  </a:t>
             </a:r>
             <a:r>
-              <a:rPr sz="2400" b="1" i="0">
+              <a:rPr sz="2400" b="0" i="0">
                 <a:solidFill>
                   <a:srgbClr val="2A2929"/>
                 </a:solidFill>
@@ -13763,7 +13629,7 @@
               <a:t>■  </a:t>
             </a:r>
             <a:r>
-              <a:rPr sz="2400" b="1" i="0">
+              <a:rPr sz="2400" b="0" i="0">
                 <a:solidFill>
                   <a:srgbClr val="2A2929"/>
                 </a:solidFill>
@@ -13825,7 +13691,7 @@
               <a:t>■  </a:t>
             </a:r>
             <a:r>
-              <a:rPr sz="2400" b="1" i="0">
+              <a:rPr sz="2400" b="0" i="0">
                 <a:solidFill>
                   <a:srgbClr val="2A2929"/>
                 </a:solidFill>
@@ -13880,16 +13746,16 @@
             <a:r>
               <a:rPr sz="2400" b="1" i="0">
                 <a:solidFill>
-                  <a:srgbClr val="92268F"/>
+                  <a:srgbClr val="EDAB0C"/>
                 </a:solidFill>
                 <a:latin typeface="Roboto"/>
               </a:rPr>
               <a:t>■  </a:t>
             </a:r>
             <a:r>
-              <a:rPr sz="2400" b="1" i="0">
-                <a:solidFill>
-                  <a:srgbClr val="92268F"/>
+              <a:rPr sz="2400" b="0" i="0">
+                <a:solidFill>
+                  <a:srgbClr val="2A2929"/>
                 </a:solidFill>
                 <a:latin typeface="Roboto"/>
               </a:rPr>
@@ -14673,16 +14539,16 @@
             <a:r>
               <a:rPr sz="2400" b="1" i="0">
                 <a:solidFill>
-                  <a:srgbClr val="92268F"/>
+                  <a:srgbClr val="EDAB0C"/>
                 </a:solidFill>
                 <a:latin typeface="Roboto"/>
               </a:rPr>
               <a:t>■  </a:t>
             </a:r>
             <a:r>
-              <a:rPr sz="2400" b="1" i="0">
-                <a:solidFill>
-                  <a:srgbClr val="92268F"/>
+              <a:rPr sz="2400" b="0" i="0">
+                <a:solidFill>
+                  <a:srgbClr val="2A2929"/>
                 </a:solidFill>
                 <a:latin typeface="Roboto"/>
               </a:rPr>
@@ -15013,7 +14879,7 @@
               <a:t>■  </a:t>
             </a:r>
             <a:r>
-              <a:rPr sz="1700" b="1" i="0">
+              <a:rPr sz="1700" b="0" i="0">
                 <a:solidFill>
                   <a:srgbClr val="2A2929"/>
                 </a:solidFill>
@@ -15223,7 +15089,7 @@
             <a:r>
               <a:rPr sz="1700" b="1" i="0">
                 <a:solidFill>
-                  <a:srgbClr val="92268F"/>
+                  <a:srgbClr val="EDAB0C"/>
                 </a:solidFill>
                 <a:latin typeface="Roboto"/>
               </a:rPr>
@@ -15232,7 +15098,7 @@
             <a:r>
               <a:rPr sz="1700" b="0" i="0">
                 <a:solidFill>
-                  <a:srgbClr val="92268F"/>
+                  <a:srgbClr val="2A2929"/>
                 </a:solidFill>
                 <a:latin typeface="Roboto"/>
               </a:rPr>

</xml_diff>